<commit_message>
Strengthen report and deck: bootstrapped CIs, references, speaker notes, icons
</commit_message>
<xml_diff>
--- a/docs/presentation.pptx
+++ b/docs/presentation.pptx
@@ -969,7 +969,7 @@
           <a:p>
             <a:r>
               <a:rPr lang="en-US" dirty="0"/>
-              <a:t/>
+              <a:t>Good morning/afternoon. This project audits three pneumonia-detection models -- not just for accuracy, but for why they fail once they leave the hospital they were trained in. I'll walk through the setup, the headline domain-shift result, and what it means for a real deployment decision.</a:t>
             </a:r>
             <a:endParaRPr lang="en-US" dirty="0"/>
           </a:p>
@@ -1057,7 +1057,7 @@
           <a:p>
             <a:r>
               <a:rPr lang="en-US" dirty="0"/>
-              <a:t/>
+              <a:t>We asked: is this shortcut reliance actually about pediatric-versus-adult age, or something more mechanical, like image resolution? The answer is mixed across architectures, which is itself informative. For the baseline CNN, age isn't significant once you control for resolution -- resolution alone explains it. For ResNet-50, all three factors are significant, including the text-marker proxy, which validates that our coarse heuristic is picking up something real. The one consistent finding across all three: age group by itself is not a reliable explanation for shortcut reliance.</a:t>
             </a:r>
             <a:endParaRPr lang="en-US" dirty="0"/>
           </a:p>
@@ -1145,7 +1145,7 @@
           <a:p>
             <a:r>
               <a:rPr lang="en-US" dirty="0"/>
-              <a:t/>
+              <a:t>Pulling this together for a deployment conversation: the training data itself needed active correction -- we found and fixed corrupted files and patient-level leakage. Shortcut reliance isn't rare, it's the majority case. Generalization isn't a single number since the two external sites disagree. And the bottom line: none of these three models should run autonomously outside a population like the training data.</a:t>
             </a:r>
             <a:endParaRPr lang="en-US" dirty="0"/>
           </a:p>
@@ -1233,7 +1233,7 @@
           <a:p>
             <a:r>
               <a:rPr lang="en-US" dirty="0"/>
-              <a:t/>
+              <a:t>A few honesty notes before the conclusion: these are real but not necessarily fully converged models. Text-marker detection is a coarse heuristic, not real OCR, since no OCR engine was available. The causal-analysis samples are modest, so individual coefficients should be read cautiously. And we only got two of the three originally planned external sites, since CheXpert and VinDr-CXR both turned out to be impractical for documented reasons, not just skipped.</a:t>
             </a:r>
             <a:endParaRPr lang="en-US" dirty="0"/>
           </a:p>
@@ -1321,7 +1321,7 @@
           <a:p>
             <a:r>
               <a:rPr lang="en-US" dirty="0"/>
-              <a:t/>
+              <a:t>So: transfer learning wins in-domain, decisively. But that in-domain edge doesn't buy trustworthy generalization -- all three models fail non-uniformly outside their training distribution, and where we can explain that failure statistically, it's resolution and detected artifacts, not an unexplained domain-shift or age label. That's the difference between a black-box excuse and a testable, actionable finding -- and a concrete argument against single-site validation as grounds for clinical deployment. Thank you.</a:t>
             </a:r>
             <a:endParaRPr lang="en-US" dirty="0"/>
           </a:p>
@@ -1409,7 +1409,7 @@
           <a:p>
             <a:r>
               <a:rPr lang="en-US" dirty="0"/>
-              <a:t/>
+              <a:t>Two published papers set this up. Zech et al. showed a pneumonia CNN partly relying on scanner artifacts instead of pathology. DeGrave et al. found the same shortcut-learning pattern in COVID classifiers. So the real question isn't just whether domain shift is real -- it's whether we can explain it with a specific, testable mechanism instead of shrugging and calling it 'domain shift.'</a:t>
             </a:r>
             <a:endParaRPr lang="en-US" dirty="0"/>
           </a:p>
@@ -1497,7 +1497,7 @@
           <a:p>
             <a:r>
               <a:rPr lang="en-US" dirty="0"/>
-              <a:t/>
+              <a:t>Five questions guided this work, but they really boil down to one thread: does the model know what pneumonia looks like, or has it learned a shortcut that happens to correlate with the training hospital? Everything after this slide is in service of answering that.</a:t>
             </a:r>
             <a:endParaRPr lang="en-US" dirty="0"/>
           </a:p>
@@ -1585,7 +1585,7 @@
           <a:p>
             <a:r>
               <a:rPr lang="en-US" dirty="0"/>
-              <a:t/>
+              <a:t>Three institutions: Kaggle's pediatric set for training, NIH and Indiana University's OpenI collection for external validation, never trained on. Note the prevalence swing -- 73 percent positive in training versus 2 to 6 percent in the external sets. That mismatch matters a lot later. Also flagging the patient-level split: images from the same patient can't leak across train and test, which the official Kaggle split doesn't guarantee on its own.</a:t>
             </a:r>
             <a:endParaRPr lang="en-US" dirty="0"/>
           </a:p>
@@ -1673,7 +1673,7 @@
           <a:p>
             <a:r>
               <a:rPr lang="en-US" dirty="0"/>
-              <a:t/>
+              <a:t>Three architectures: a from-scratch baseline CNN, and two ImageNet-pretrained transfer models, ResNet-50 and DenseNet-121. The evaluation pipeline runs statistical testing, three-way domain-shift evaluation, Grad-CAM auditing, a border-masking ablation, and a causal regression -- I'll walk through each of these in turn.</a:t>
             </a:r>
             <a:endParaRPr lang="en-US" dirty="0"/>
           </a:p>
@@ -1761,7 +1761,7 @@
           <a:p>
             <a:r>
               <a:rPr lang="en-US" dirty="0"/>
-              <a:t/>
+              <a:t>In-domain, both transfer models clearly beat the baseline, and McNemar's test confirms that's not noise -- p less than 0.001 for both comparisons. Interestingly, ResNet-50 and DenseNet-121 are statistically indistinguishable from each other. So transfer learning matters; which specific pretrained backbone you pick, less so.</a:t>
             </a:r>
             <a:endParaRPr lang="en-US" dirty="0"/>
           </a:p>
@@ -1849,7 +1849,7 @@
           <a:p>
             <a:r>
               <a:rPr lang="en-US" dirty="0"/>
-              <a:t/>
+              <a:t>Here's the headline result. All three models collapse when moved to external data, but not the same way -- baseline CNN's AUC-ROC on OpenI is 0.512, with a bootstrapped confidence interval that actually straddles 0.5, so it's not reliably better than chance. ResNet-50 flips the ranking between NIH and OpenI. If domain shift were one monolithic effect, every model would rank the two external sites the same way. They don't -- direct evidence this isn't a single unexplained black-box effect.</a:t>
             </a:r>
             <a:endParaRPr lang="en-US" dirty="0"/>
           </a:p>
@@ -1937,7 +1937,7 @@
           <a:p>
             <a:r>
               <a:rPr lang="en-US" dirty="0"/>
-              <a:t/>
+              <a:t>This is the quantitative core of the shortcut-learning claim. Even on correct predictions, Grad-CAM attention overlaps the segmented lung field only 12 to 16 percent of the time, and 74 to 81 percent of correct predictions fall under our 30 percent shortcut threshold. The border-masking test adds a mechanistic detail: blanking the outer 10 percent of the image costs the baseline CNN almost 15 accuracy points, but barely touches the transfer models -- so the specific shortcut differs by architecture, even though all three are looking somewhere they shouldn't.</a:t>
             </a:r>
             <a:endParaRPr lang="en-US" dirty="0"/>
           </a:p>
@@ -2025,7 +2025,7 @@
           <a:p>
             <a:r>
               <a:rPr lang="en-US" dirty="0"/>
-              <a:t/>
+              <a:t>This single case makes the abstract statistic concrete. Normal chest X-ray, predicted pneumonia with 100 percent confidence -- and the entire Grad-CAM attention sits on the letter R laterality marker in the corner. Maximum confidence, and completely wrong for a reason that has nothing to do with the lungs.</a:t>
             </a:r>
             <a:endParaRPr lang="en-US" dirty="0"/>
           </a:p>
@@ -2572,14 +2572,58 @@
       </p:grpSpPr>
       <p:sp>
         <p:nvSpPr>
-          <p:cNvPr id="2" name="Text 0"/>
-          <p:cNvSpPr/>
-          <p:nvPr/>
-        </p:nvSpPr>
-        <p:spPr>
-          <a:xfrm>
-            <a:off x="548640" y="384048"/>
-            <a:ext cx="11091672" cy="320040"/>
+          <p:cNvPr id="2" name="Shape 0"/>
+          <p:cNvSpPr/>
+          <p:nvPr/>
+        </p:nvSpPr>
+        <p:spPr>
+          <a:xfrm>
+            <a:off x="548640" y="365760"/>
+            <a:ext cx="365760" cy="365760"/>
+          </a:xfrm>
+          <a:prstGeom prst="ellipse">
+            <a:avLst/>
+          </a:prstGeom>
+          <a:solidFill>
+            <a:srgbClr val="1E2761"/>
+          </a:solidFill>
+          <a:ln/>
+        </p:spPr>
+      </p:sp>
+      <p:pic>
+        <p:nvPicPr>
+          <p:cNvPr id="3" name="Image 0" descr="preencoded.png">    </p:cNvPr>
+          <p:cNvPicPr>
+            <a:picLocks noChangeAspect="1"/>
+          </p:cNvPicPr>
+          <p:nvPr/>
+        </p:nvPicPr>
+        <p:blipFill>
+          <a:blip r:embed="rId1"/>
+          <a:stretch>
+            <a:fillRect/>
+          </a:stretch>
+        </p:blipFill>
+        <p:spPr>
+          <a:xfrm>
+            <a:off x="649224" y="466344"/>
+            <a:ext cx="164592" cy="164592"/>
+          </a:xfrm>
+          <a:prstGeom prst="rect">
+            <a:avLst/>
+          </a:prstGeom>
+        </p:spPr>
+      </p:pic>
+      <p:sp>
+        <p:nvSpPr>
+          <p:cNvPr id="4" name="Text 1"/>
+          <p:cNvSpPr/>
+          <p:nvPr/>
+        </p:nvSpPr>
+        <p:spPr>
+          <a:xfrm>
+            <a:off x="1051560" y="384048"/>
+            <a:ext cx="10588752" cy="320040"/>
           </a:xfrm>
           <a:prstGeom prst="rect">
             <a:avLst/>
@@ -2611,7 +2655,7 @@
       </p:sp>
       <p:sp>
         <p:nvSpPr>
-          <p:cNvPr id="3" name="Text 1"/>
+          <p:cNvPr id="5" name="Text 2"/>
           <p:cNvSpPr/>
           <p:nvPr/>
         </p:nvSpPr>
@@ -2650,7 +2694,7 @@
       </p:sp>
       <p:sp>
         <p:nvSpPr>
-          <p:cNvPr id="4" name="Text 2"/>
+          <p:cNvPr id="6" name="Text 3"/>
           <p:cNvSpPr/>
           <p:nvPr/>
         </p:nvSpPr>
@@ -4363,7 +4407,7 @@
       </p:graphicFrame>
       <p:sp>
         <p:nvSpPr>
-          <p:cNvPr id="6" name="Shape 3"/>
+          <p:cNvPr id="8" name="Shape 4"/>
           <p:cNvSpPr/>
           <p:nvPr/>
         </p:nvSpPr>
@@ -4385,7 +4429,7 @@
       </p:sp>
       <p:sp>
         <p:nvSpPr>
-          <p:cNvPr id="7" name="Text 4"/>
+          <p:cNvPr id="9" name="Text 5"/>
           <p:cNvSpPr/>
           <p:nvPr/>
         </p:nvSpPr>
@@ -4424,7 +4468,7 @@
       </p:sp>
       <p:sp>
         <p:nvSpPr>
-          <p:cNvPr id="8" name="Text 5"/>
+          <p:cNvPr id="10" name="Text 6"/>
           <p:cNvSpPr/>
           <p:nvPr/>
         </p:nvSpPr>
@@ -4466,7 +4510,7 @@
       </p:sp>
       <p:sp>
         <p:nvSpPr>
-          <p:cNvPr id="9" name="Text 6"/>
+          <p:cNvPr id="11" name="Text 7"/>
           <p:cNvSpPr/>
           <p:nvPr/>
         </p:nvSpPr>
@@ -4537,14 +4581,58 @@
       </p:grpSpPr>
       <p:sp>
         <p:nvSpPr>
-          <p:cNvPr id="2" name="Text 0"/>
-          <p:cNvSpPr/>
-          <p:nvPr/>
-        </p:nvSpPr>
-        <p:spPr>
-          <a:xfrm>
-            <a:off x="548640" y="384048"/>
-            <a:ext cx="11091672" cy="320040"/>
+          <p:cNvPr id="2" name="Shape 0"/>
+          <p:cNvSpPr/>
+          <p:nvPr/>
+        </p:nvSpPr>
+        <p:spPr>
+          <a:xfrm>
+            <a:off x="548640" y="365760"/>
+            <a:ext cx="365760" cy="365760"/>
+          </a:xfrm>
+          <a:prstGeom prst="ellipse">
+            <a:avLst/>
+          </a:prstGeom>
+          <a:solidFill>
+            <a:srgbClr val="1E2761"/>
+          </a:solidFill>
+          <a:ln/>
+        </p:spPr>
+      </p:sp>
+      <p:pic>
+        <p:nvPicPr>
+          <p:cNvPr id="3" name="Image 0" descr="preencoded.png">    </p:cNvPr>
+          <p:cNvPicPr>
+            <a:picLocks noChangeAspect="1"/>
+          </p:cNvPicPr>
+          <p:nvPr/>
+        </p:nvPicPr>
+        <p:blipFill>
+          <a:blip r:embed="rId1"/>
+          <a:stretch>
+            <a:fillRect/>
+          </a:stretch>
+        </p:blipFill>
+        <p:spPr>
+          <a:xfrm>
+            <a:off x="649224" y="466344"/>
+            <a:ext cx="164592" cy="164592"/>
+          </a:xfrm>
+          <a:prstGeom prst="rect">
+            <a:avLst/>
+          </a:prstGeom>
+        </p:spPr>
+      </p:pic>
+      <p:sp>
+        <p:nvSpPr>
+          <p:cNvPr id="4" name="Text 1"/>
+          <p:cNvSpPr/>
+          <p:nvPr/>
+        </p:nvSpPr>
+        <p:spPr>
+          <a:xfrm>
+            <a:off x="1051560" y="384048"/>
+            <a:ext cx="10588752" cy="320040"/>
           </a:xfrm>
           <a:prstGeom prst="rect">
             <a:avLst/>
@@ -4576,7 +4664,7 @@
       </p:sp>
       <p:sp>
         <p:nvSpPr>
-          <p:cNvPr id="3" name="Text 1"/>
+          <p:cNvPr id="5" name="Text 2"/>
           <p:cNvSpPr/>
           <p:nvPr/>
         </p:nvSpPr>
@@ -4615,7 +4703,7 @@
       </p:sp>
       <p:sp>
         <p:nvSpPr>
-          <p:cNvPr id="4" name="Shape 2"/>
+          <p:cNvPr id="6" name="Shape 3"/>
           <p:cNvSpPr/>
           <p:nvPr/>
         </p:nvSpPr>
@@ -4637,7 +4725,7 @@
       </p:sp>
       <p:sp>
         <p:nvSpPr>
-          <p:cNvPr id="5" name="Text 3"/>
+          <p:cNvPr id="7" name="Text 4"/>
           <p:cNvSpPr/>
           <p:nvPr/>
         </p:nvSpPr>
@@ -4676,7 +4764,7 @@
       </p:sp>
       <p:sp>
         <p:nvSpPr>
-          <p:cNvPr id="6" name="Text 4"/>
+          <p:cNvPr id="8" name="Text 5"/>
           <p:cNvSpPr/>
           <p:nvPr/>
         </p:nvSpPr>
@@ -4718,7 +4806,7 @@
       </p:sp>
       <p:sp>
         <p:nvSpPr>
-          <p:cNvPr id="7" name="Shape 5"/>
+          <p:cNvPr id="9" name="Shape 6"/>
           <p:cNvSpPr/>
           <p:nvPr/>
         </p:nvSpPr>
@@ -4740,7 +4828,7 @@
       </p:sp>
       <p:sp>
         <p:nvSpPr>
-          <p:cNvPr id="8" name="Text 6"/>
+          <p:cNvPr id="10" name="Text 7"/>
           <p:cNvSpPr/>
           <p:nvPr/>
         </p:nvSpPr>
@@ -4779,7 +4867,7 @@
       </p:sp>
       <p:sp>
         <p:nvSpPr>
-          <p:cNvPr id="9" name="Text 7"/>
+          <p:cNvPr id="11" name="Text 8"/>
           <p:cNvSpPr/>
           <p:nvPr/>
         </p:nvSpPr>
@@ -4821,7 +4909,7 @@
       </p:sp>
       <p:sp>
         <p:nvSpPr>
-          <p:cNvPr id="10" name="Shape 8"/>
+          <p:cNvPr id="12" name="Shape 9"/>
           <p:cNvSpPr/>
           <p:nvPr/>
         </p:nvSpPr>
@@ -4843,7 +4931,7 @@
       </p:sp>
       <p:sp>
         <p:nvSpPr>
-          <p:cNvPr id="11" name="Text 9"/>
+          <p:cNvPr id="13" name="Text 10"/>
           <p:cNvSpPr/>
           <p:nvPr/>
         </p:nvSpPr>
@@ -4882,7 +4970,7 @@
       </p:sp>
       <p:sp>
         <p:nvSpPr>
-          <p:cNvPr id="12" name="Text 10"/>
+          <p:cNvPr id="14" name="Text 11"/>
           <p:cNvSpPr/>
           <p:nvPr/>
         </p:nvSpPr>
@@ -4924,7 +5012,7 @@
       </p:sp>
       <p:sp>
         <p:nvSpPr>
-          <p:cNvPr id="13" name="Shape 11"/>
+          <p:cNvPr id="15" name="Shape 12"/>
           <p:cNvSpPr/>
           <p:nvPr/>
         </p:nvSpPr>
@@ -4946,7 +5034,7 @@
       </p:sp>
       <p:sp>
         <p:nvSpPr>
-          <p:cNvPr id="14" name="Text 12"/>
+          <p:cNvPr id="16" name="Text 13"/>
           <p:cNvSpPr/>
           <p:nvPr/>
         </p:nvSpPr>
@@ -4985,7 +5073,7 @@
       </p:sp>
       <p:sp>
         <p:nvSpPr>
-          <p:cNvPr id="15" name="Text 13"/>
+          <p:cNvPr id="17" name="Text 14"/>
           <p:cNvSpPr/>
           <p:nvPr/>
         </p:nvSpPr>
@@ -5027,7 +5115,7 @@
       </p:sp>
       <p:sp>
         <p:nvSpPr>
-          <p:cNvPr id="16" name="Text 14"/>
+          <p:cNvPr id="18" name="Text 15"/>
           <p:cNvSpPr/>
           <p:nvPr/>
         </p:nvSpPr>
@@ -5098,14 +5186,58 @@
       </p:grpSpPr>
       <p:sp>
         <p:nvSpPr>
-          <p:cNvPr id="2" name="Text 0"/>
-          <p:cNvSpPr/>
-          <p:nvPr/>
-        </p:nvSpPr>
-        <p:spPr>
-          <a:xfrm>
-            <a:off x="548640" y="384048"/>
-            <a:ext cx="11091672" cy="320040"/>
+          <p:cNvPr id="2" name="Shape 0"/>
+          <p:cNvSpPr/>
+          <p:nvPr/>
+        </p:nvSpPr>
+        <p:spPr>
+          <a:xfrm>
+            <a:off x="548640" y="365760"/>
+            <a:ext cx="365760" cy="365760"/>
+          </a:xfrm>
+          <a:prstGeom prst="ellipse">
+            <a:avLst/>
+          </a:prstGeom>
+          <a:solidFill>
+            <a:srgbClr val="1E2761"/>
+          </a:solidFill>
+          <a:ln/>
+        </p:spPr>
+      </p:sp>
+      <p:pic>
+        <p:nvPicPr>
+          <p:cNvPr id="3" name="Image 0" descr="preencoded.png">    </p:cNvPr>
+          <p:cNvPicPr>
+            <a:picLocks noChangeAspect="1"/>
+          </p:cNvPicPr>
+          <p:nvPr/>
+        </p:nvPicPr>
+        <p:blipFill>
+          <a:blip r:embed="rId1"/>
+          <a:stretch>
+            <a:fillRect/>
+          </a:stretch>
+        </p:blipFill>
+        <p:spPr>
+          <a:xfrm>
+            <a:off x="649224" y="466344"/>
+            <a:ext cx="164592" cy="164592"/>
+          </a:xfrm>
+          <a:prstGeom prst="rect">
+            <a:avLst/>
+          </a:prstGeom>
+        </p:spPr>
+      </p:pic>
+      <p:sp>
+        <p:nvSpPr>
+          <p:cNvPr id="4" name="Text 1"/>
+          <p:cNvSpPr/>
+          <p:nvPr/>
+        </p:nvSpPr>
+        <p:spPr>
+          <a:xfrm>
+            <a:off x="1051560" y="384048"/>
+            <a:ext cx="10588752" cy="320040"/>
           </a:xfrm>
           <a:prstGeom prst="rect">
             <a:avLst/>
@@ -5137,7 +5269,7 @@
       </p:sp>
       <p:sp>
         <p:nvSpPr>
-          <p:cNvPr id="3" name="Text 1"/>
+          <p:cNvPr id="5" name="Text 2"/>
           <p:cNvSpPr/>
           <p:nvPr/>
         </p:nvSpPr>
@@ -5176,7 +5308,7 @@
       </p:sp>
       <p:sp>
         <p:nvSpPr>
-          <p:cNvPr id="4" name="Shape 2"/>
+          <p:cNvPr id="6" name="Shape 3"/>
           <p:cNvSpPr/>
           <p:nvPr/>
         </p:nvSpPr>
@@ -5196,7 +5328,7 @@
       </p:sp>
       <p:sp>
         <p:nvSpPr>
-          <p:cNvPr id="5" name="Text 3"/>
+          <p:cNvPr id="7" name="Text 4"/>
           <p:cNvSpPr/>
           <p:nvPr/>
         </p:nvSpPr>
@@ -5238,7 +5370,7 @@
       </p:sp>
       <p:sp>
         <p:nvSpPr>
-          <p:cNvPr id="6" name="Shape 4"/>
+          <p:cNvPr id="8" name="Shape 5"/>
           <p:cNvSpPr/>
           <p:nvPr/>
         </p:nvSpPr>
@@ -5258,7 +5390,7 @@
       </p:sp>
       <p:sp>
         <p:nvSpPr>
-          <p:cNvPr id="7" name="Text 5"/>
+          <p:cNvPr id="9" name="Text 6"/>
           <p:cNvSpPr/>
           <p:nvPr/>
         </p:nvSpPr>
@@ -5300,7 +5432,7 @@
       </p:sp>
       <p:sp>
         <p:nvSpPr>
-          <p:cNvPr id="8" name="Shape 6"/>
+          <p:cNvPr id="10" name="Shape 7"/>
           <p:cNvSpPr/>
           <p:nvPr/>
         </p:nvSpPr>
@@ -5320,7 +5452,7 @@
       </p:sp>
       <p:sp>
         <p:nvSpPr>
-          <p:cNvPr id="9" name="Text 7"/>
+          <p:cNvPr id="11" name="Text 8"/>
           <p:cNvSpPr/>
           <p:nvPr/>
         </p:nvSpPr>
@@ -5362,7 +5494,7 @@
       </p:sp>
       <p:sp>
         <p:nvSpPr>
-          <p:cNvPr id="10" name="Shape 8"/>
+          <p:cNvPr id="12" name="Shape 9"/>
           <p:cNvSpPr/>
           <p:nvPr/>
         </p:nvSpPr>
@@ -5382,7 +5514,7 @@
       </p:sp>
       <p:sp>
         <p:nvSpPr>
-          <p:cNvPr id="11" name="Text 9"/>
+          <p:cNvPr id="13" name="Text 10"/>
           <p:cNvSpPr/>
           <p:nvPr/>
         </p:nvSpPr>
@@ -5424,7 +5556,7 @@
       </p:sp>
       <p:sp>
         <p:nvSpPr>
-          <p:cNvPr id="12" name="Shape 10"/>
+          <p:cNvPr id="14" name="Shape 11"/>
           <p:cNvSpPr/>
           <p:nvPr/>
         </p:nvSpPr>
@@ -5444,7 +5576,7 @@
       </p:sp>
       <p:sp>
         <p:nvSpPr>
-          <p:cNvPr id="13" name="Text 11"/>
+          <p:cNvPr id="15" name="Text 12"/>
           <p:cNvSpPr/>
           <p:nvPr/>
         </p:nvSpPr>
@@ -5486,7 +5618,7 @@
       </p:sp>
       <p:sp>
         <p:nvSpPr>
-          <p:cNvPr id="14" name="Text 12"/>
+          <p:cNvPr id="16" name="Text 13"/>
           <p:cNvSpPr/>
           <p:nvPr/>
         </p:nvSpPr>
@@ -5957,14 +6089,58 @@
       </p:grpSpPr>
       <p:sp>
         <p:nvSpPr>
-          <p:cNvPr id="2" name="Text 0"/>
-          <p:cNvSpPr/>
-          <p:nvPr/>
-        </p:nvSpPr>
-        <p:spPr>
-          <a:xfrm>
-            <a:off x="548640" y="384048"/>
-            <a:ext cx="11091672" cy="320040"/>
+          <p:cNvPr id="2" name="Shape 0"/>
+          <p:cNvSpPr/>
+          <p:nvPr/>
+        </p:nvSpPr>
+        <p:spPr>
+          <a:xfrm>
+            <a:off x="548640" y="365760"/>
+            <a:ext cx="365760" cy="365760"/>
+          </a:xfrm>
+          <a:prstGeom prst="ellipse">
+            <a:avLst/>
+          </a:prstGeom>
+          <a:solidFill>
+            <a:srgbClr val="1E2761"/>
+          </a:solidFill>
+          <a:ln/>
+        </p:spPr>
+      </p:sp>
+      <p:pic>
+        <p:nvPicPr>
+          <p:cNvPr id="3" name="Image 0" descr="preencoded.png">    </p:cNvPr>
+          <p:cNvPicPr>
+            <a:picLocks noChangeAspect="1"/>
+          </p:cNvPicPr>
+          <p:nvPr/>
+        </p:nvPicPr>
+        <p:blipFill>
+          <a:blip r:embed="rId1"/>
+          <a:stretch>
+            <a:fillRect/>
+          </a:stretch>
+        </p:blipFill>
+        <p:spPr>
+          <a:xfrm>
+            <a:off x="649224" y="466344"/>
+            <a:ext cx="164592" cy="164592"/>
+          </a:xfrm>
+          <a:prstGeom prst="rect">
+            <a:avLst/>
+          </a:prstGeom>
+        </p:spPr>
+      </p:pic>
+      <p:sp>
+        <p:nvSpPr>
+          <p:cNvPr id="4" name="Text 1"/>
+          <p:cNvSpPr/>
+          <p:nvPr/>
+        </p:nvSpPr>
+        <p:spPr>
+          <a:xfrm>
+            <a:off x="1051560" y="384048"/>
+            <a:ext cx="10588752" cy="320040"/>
           </a:xfrm>
           <a:prstGeom prst="rect">
             <a:avLst/>
@@ -5996,7 +6172,7 @@
       </p:sp>
       <p:sp>
         <p:nvSpPr>
-          <p:cNvPr id="3" name="Text 1"/>
+          <p:cNvPr id="5" name="Text 2"/>
           <p:cNvSpPr/>
           <p:nvPr/>
         </p:nvSpPr>
@@ -6035,7 +6211,7 @@
       </p:sp>
       <p:sp>
         <p:nvSpPr>
-          <p:cNvPr id="4" name="Text 2"/>
+          <p:cNvPr id="6" name="Text 3"/>
           <p:cNvSpPr/>
           <p:nvPr/>
         </p:nvSpPr>
@@ -6077,7 +6253,7 @@
       </p:sp>
       <p:sp>
         <p:nvSpPr>
-          <p:cNvPr id="5" name="Shape 3"/>
+          <p:cNvPr id="7" name="Shape 4"/>
           <p:cNvSpPr/>
           <p:nvPr/>
         </p:nvSpPr>
@@ -6099,7 +6275,7 @@
       </p:sp>
       <p:sp>
         <p:nvSpPr>
-          <p:cNvPr id="6" name="Text 4"/>
+          <p:cNvPr id="8" name="Text 5"/>
           <p:cNvSpPr/>
           <p:nvPr/>
         </p:nvSpPr>
@@ -6138,7 +6314,7 @@
       </p:sp>
       <p:sp>
         <p:nvSpPr>
-          <p:cNvPr id="7" name="Text 5"/>
+          <p:cNvPr id="9" name="Text 6"/>
           <p:cNvSpPr/>
           <p:nvPr/>
         </p:nvSpPr>
@@ -6180,7 +6356,7 @@
       </p:sp>
       <p:sp>
         <p:nvSpPr>
-          <p:cNvPr id="8" name="Shape 6"/>
+          <p:cNvPr id="10" name="Shape 7"/>
           <p:cNvSpPr/>
           <p:nvPr/>
         </p:nvSpPr>
@@ -6202,7 +6378,7 @@
       </p:sp>
       <p:sp>
         <p:nvSpPr>
-          <p:cNvPr id="9" name="Text 7"/>
+          <p:cNvPr id="11" name="Text 8"/>
           <p:cNvSpPr/>
           <p:nvPr/>
         </p:nvSpPr>
@@ -6241,7 +6417,7 @@
       </p:sp>
       <p:sp>
         <p:nvSpPr>
-          <p:cNvPr id="10" name="Text 8"/>
+          <p:cNvPr id="12" name="Text 9"/>
           <p:cNvSpPr/>
           <p:nvPr/>
         </p:nvSpPr>
@@ -6283,7 +6459,7 @@
       </p:sp>
       <p:sp>
         <p:nvSpPr>
-          <p:cNvPr id="11" name="Shape 9"/>
+          <p:cNvPr id="13" name="Shape 10"/>
           <p:cNvSpPr/>
           <p:nvPr/>
         </p:nvSpPr>
@@ -6305,7 +6481,7 @@
       </p:sp>
       <p:sp>
         <p:nvSpPr>
-          <p:cNvPr id="12" name="Text 10"/>
+          <p:cNvPr id="14" name="Text 11"/>
           <p:cNvSpPr/>
           <p:nvPr/>
         </p:nvSpPr>
@@ -6344,7 +6520,7 @@
       </p:sp>
       <p:sp>
         <p:nvSpPr>
-          <p:cNvPr id="13" name="Text 11"/>
+          <p:cNvPr id="15" name="Text 12"/>
           <p:cNvSpPr/>
           <p:nvPr/>
         </p:nvSpPr>
@@ -6386,7 +6562,7 @@
       </p:sp>
       <p:sp>
         <p:nvSpPr>
-          <p:cNvPr id="14" name="Text 12"/>
+          <p:cNvPr id="16" name="Text 13"/>
           <p:cNvSpPr/>
           <p:nvPr/>
         </p:nvSpPr>
@@ -6428,7 +6604,7 @@
       </p:sp>
       <p:sp>
         <p:nvSpPr>
-          <p:cNvPr id="15" name="Text 13"/>
+          <p:cNvPr id="17" name="Text 14"/>
           <p:cNvSpPr/>
           <p:nvPr/>
         </p:nvSpPr>
@@ -6499,14 +6675,58 @@
       </p:grpSpPr>
       <p:sp>
         <p:nvSpPr>
-          <p:cNvPr id="2" name="Text 0"/>
-          <p:cNvSpPr/>
-          <p:nvPr/>
-        </p:nvSpPr>
-        <p:spPr>
-          <a:xfrm>
-            <a:off x="548640" y="384048"/>
-            <a:ext cx="11091672" cy="320040"/>
+          <p:cNvPr id="2" name="Shape 0"/>
+          <p:cNvSpPr/>
+          <p:nvPr/>
+        </p:nvSpPr>
+        <p:spPr>
+          <a:xfrm>
+            <a:off x="548640" y="365760"/>
+            <a:ext cx="365760" cy="365760"/>
+          </a:xfrm>
+          <a:prstGeom prst="ellipse">
+            <a:avLst/>
+          </a:prstGeom>
+          <a:solidFill>
+            <a:srgbClr val="1E2761"/>
+          </a:solidFill>
+          <a:ln/>
+        </p:spPr>
+      </p:sp>
+      <p:pic>
+        <p:nvPicPr>
+          <p:cNvPr id="3" name="Image 0" descr="preencoded.png">    </p:cNvPr>
+          <p:cNvPicPr>
+            <a:picLocks noChangeAspect="1"/>
+          </p:cNvPicPr>
+          <p:nvPr/>
+        </p:nvPicPr>
+        <p:blipFill>
+          <a:blip r:embed="rId1"/>
+          <a:stretch>
+            <a:fillRect/>
+          </a:stretch>
+        </p:blipFill>
+        <p:spPr>
+          <a:xfrm>
+            <a:off x="649224" y="466344"/>
+            <a:ext cx="164592" cy="164592"/>
+          </a:xfrm>
+          <a:prstGeom prst="rect">
+            <a:avLst/>
+          </a:prstGeom>
+        </p:spPr>
+      </p:pic>
+      <p:sp>
+        <p:nvSpPr>
+          <p:cNvPr id="4" name="Text 1"/>
+          <p:cNvSpPr/>
+          <p:nvPr/>
+        </p:nvSpPr>
+        <p:spPr>
+          <a:xfrm>
+            <a:off x="1051560" y="384048"/>
+            <a:ext cx="10588752" cy="320040"/>
           </a:xfrm>
           <a:prstGeom prst="rect">
             <a:avLst/>
@@ -6538,7 +6758,7 @@
       </p:sp>
       <p:sp>
         <p:nvSpPr>
-          <p:cNvPr id="3" name="Text 1"/>
+          <p:cNvPr id="5" name="Text 2"/>
           <p:cNvSpPr/>
           <p:nvPr/>
         </p:nvSpPr>
@@ -6577,7 +6797,7 @@
       </p:sp>
       <p:sp>
         <p:nvSpPr>
-          <p:cNvPr id="4" name="Shape 2"/>
+          <p:cNvPr id="6" name="Shape 3"/>
           <p:cNvSpPr/>
           <p:nvPr/>
         </p:nvSpPr>
@@ -6597,7 +6817,7 @@
       </p:sp>
       <p:sp>
         <p:nvSpPr>
-          <p:cNvPr id="5" name="Text 3"/>
+          <p:cNvPr id="7" name="Text 4"/>
           <p:cNvSpPr/>
           <p:nvPr/>
         </p:nvSpPr>
@@ -6636,7 +6856,7 @@
       </p:sp>
       <p:sp>
         <p:nvSpPr>
-          <p:cNvPr id="6" name="Text 4"/>
+          <p:cNvPr id="8" name="Text 5"/>
           <p:cNvSpPr/>
           <p:nvPr/>
         </p:nvSpPr>
@@ -6678,7 +6898,7 @@
       </p:sp>
       <p:sp>
         <p:nvSpPr>
-          <p:cNvPr id="7" name="Shape 5"/>
+          <p:cNvPr id="9" name="Shape 6"/>
           <p:cNvSpPr/>
           <p:nvPr/>
         </p:nvSpPr>
@@ -6698,7 +6918,7 @@
       </p:sp>
       <p:sp>
         <p:nvSpPr>
-          <p:cNvPr id="8" name="Text 6"/>
+          <p:cNvPr id="10" name="Text 7"/>
           <p:cNvSpPr/>
           <p:nvPr/>
         </p:nvSpPr>
@@ -6737,7 +6957,7 @@
       </p:sp>
       <p:sp>
         <p:nvSpPr>
-          <p:cNvPr id="9" name="Text 7"/>
+          <p:cNvPr id="11" name="Text 8"/>
           <p:cNvSpPr/>
           <p:nvPr/>
         </p:nvSpPr>
@@ -6779,7 +6999,7 @@
       </p:sp>
       <p:sp>
         <p:nvSpPr>
-          <p:cNvPr id="10" name="Shape 8"/>
+          <p:cNvPr id="12" name="Shape 9"/>
           <p:cNvSpPr/>
           <p:nvPr/>
         </p:nvSpPr>
@@ -6799,7 +7019,7 @@
       </p:sp>
       <p:sp>
         <p:nvSpPr>
-          <p:cNvPr id="11" name="Text 9"/>
+          <p:cNvPr id="13" name="Text 10"/>
           <p:cNvSpPr/>
           <p:nvPr/>
         </p:nvSpPr>
@@ -6838,7 +7058,7 @@
       </p:sp>
       <p:sp>
         <p:nvSpPr>
-          <p:cNvPr id="12" name="Text 10"/>
+          <p:cNvPr id="14" name="Text 11"/>
           <p:cNvSpPr/>
           <p:nvPr/>
         </p:nvSpPr>
@@ -6880,7 +7100,7 @@
       </p:sp>
       <p:sp>
         <p:nvSpPr>
-          <p:cNvPr id="13" name="Shape 11"/>
+          <p:cNvPr id="15" name="Shape 12"/>
           <p:cNvSpPr/>
           <p:nvPr/>
         </p:nvSpPr>
@@ -6900,7 +7120,7 @@
       </p:sp>
       <p:sp>
         <p:nvSpPr>
-          <p:cNvPr id="14" name="Text 12"/>
+          <p:cNvPr id="16" name="Text 13"/>
           <p:cNvSpPr/>
           <p:nvPr/>
         </p:nvSpPr>
@@ -6939,7 +7159,7 @@
       </p:sp>
       <p:sp>
         <p:nvSpPr>
-          <p:cNvPr id="15" name="Text 13"/>
+          <p:cNvPr id="17" name="Text 14"/>
           <p:cNvSpPr/>
           <p:nvPr/>
         </p:nvSpPr>
@@ -6981,7 +7201,7 @@
       </p:sp>
       <p:sp>
         <p:nvSpPr>
-          <p:cNvPr id="16" name="Shape 14"/>
+          <p:cNvPr id="18" name="Shape 15"/>
           <p:cNvSpPr/>
           <p:nvPr/>
         </p:nvSpPr>
@@ -7001,7 +7221,7 @@
       </p:sp>
       <p:sp>
         <p:nvSpPr>
-          <p:cNvPr id="17" name="Text 15"/>
+          <p:cNvPr id="19" name="Text 16"/>
           <p:cNvSpPr/>
           <p:nvPr/>
         </p:nvSpPr>
@@ -7040,7 +7260,7 @@
       </p:sp>
       <p:sp>
         <p:nvSpPr>
-          <p:cNvPr id="18" name="Text 16"/>
+          <p:cNvPr id="20" name="Text 17"/>
           <p:cNvSpPr/>
           <p:nvPr/>
         </p:nvSpPr>
@@ -7082,7 +7302,7 @@
       </p:sp>
       <p:sp>
         <p:nvSpPr>
-          <p:cNvPr id="19" name="Text 17"/>
+          <p:cNvPr id="21" name="Text 18"/>
           <p:cNvSpPr/>
           <p:nvPr/>
         </p:nvSpPr>
@@ -7153,14 +7373,58 @@
       </p:grpSpPr>
       <p:sp>
         <p:nvSpPr>
-          <p:cNvPr id="2" name="Text 0"/>
-          <p:cNvSpPr/>
-          <p:nvPr/>
-        </p:nvSpPr>
-        <p:spPr>
-          <a:xfrm>
-            <a:off x="548640" y="384048"/>
-            <a:ext cx="11091672" cy="320040"/>
+          <p:cNvPr id="2" name="Shape 0"/>
+          <p:cNvSpPr/>
+          <p:nvPr/>
+        </p:nvSpPr>
+        <p:spPr>
+          <a:xfrm>
+            <a:off x="548640" y="365760"/>
+            <a:ext cx="365760" cy="365760"/>
+          </a:xfrm>
+          <a:prstGeom prst="ellipse">
+            <a:avLst/>
+          </a:prstGeom>
+          <a:solidFill>
+            <a:srgbClr val="1E2761"/>
+          </a:solidFill>
+          <a:ln/>
+        </p:spPr>
+      </p:sp>
+      <p:pic>
+        <p:nvPicPr>
+          <p:cNvPr id="3" name="Image 0" descr="preencoded.png">    </p:cNvPr>
+          <p:cNvPicPr>
+            <a:picLocks noChangeAspect="1"/>
+          </p:cNvPicPr>
+          <p:nvPr/>
+        </p:nvPicPr>
+        <p:blipFill>
+          <a:blip r:embed="rId1"/>
+          <a:stretch>
+            <a:fillRect/>
+          </a:stretch>
+        </p:blipFill>
+        <p:spPr>
+          <a:xfrm>
+            <a:off x="649224" y="466344"/>
+            <a:ext cx="164592" cy="164592"/>
+          </a:xfrm>
+          <a:prstGeom prst="rect">
+            <a:avLst/>
+          </a:prstGeom>
+        </p:spPr>
+      </p:pic>
+      <p:sp>
+        <p:nvSpPr>
+          <p:cNvPr id="4" name="Text 1"/>
+          <p:cNvSpPr/>
+          <p:nvPr/>
+        </p:nvSpPr>
+        <p:spPr>
+          <a:xfrm>
+            <a:off x="1051560" y="384048"/>
+            <a:ext cx="10588752" cy="320040"/>
           </a:xfrm>
           <a:prstGeom prst="rect">
             <a:avLst/>
@@ -7192,7 +7456,7 @@
       </p:sp>
       <p:sp>
         <p:nvSpPr>
-          <p:cNvPr id="3" name="Text 1"/>
+          <p:cNvPr id="5" name="Text 2"/>
           <p:cNvSpPr/>
           <p:nvPr/>
         </p:nvSpPr>
@@ -7231,7 +7495,7 @@
       </p:sp>
       <p:sp>
         <p:nvSpPr>
-          <p:cNvPr id="4" name="Shape 2"/>
+          <p:cNvPr id="6" name="Shape 3"/>
           <p:cNvSpPr/>
           <p:nvPr/>
         </p:nvSpPr>
@@ -7253,7 +7517,7 @@
       </p:sp>
       <p:sp>
         <p:nvSpPr>
-          <p:cNvPr id="5" name="Text 3"/>
+          <p:cNvPr id="7" name="Text 4"/>
           <p:cNvSpPr/>
           <p:nvPr/>
         </p:nvSpPr>
@@ -7292,7 +7556,7 @@
       </p:sp>
       <p:sp>
         <p:nvSpPr>
-          <p:cNvPr id="6" name="Text 4"/>
+          <p:cNvPr id="8" name="Text 5"/>
           <p:cNvSpPr/>
           <p:nvPr/>
         </p:nvSpPr>
@@ -7331,7 +7595,7 @@
       </p:sp>
       <p:sp>
         <p:nvSpPr>
-          <p:cNvPr id="7" name="Text 5"/>
+          <p:cNvPr id="9" name="Text 6"/>
           <p:cNvSpPr/>
           <p:nvPr/>
         </p:nvSpPr>
@@ -7373,7 +7637,7 @@
       </p:sp>
       <p:sp>
         <p:nvSpPr>
-          <p:cNvPr id="8" name="Text 6"/>
+          <p:cNvPr id="10" name="Text 7"/>
           <p:cNvSpPr/>
           <p:nvPr/>
         </p:nvSpPr>
@@ -7412,7 +7676,7 @@
       </p:sp>
       <p:sp>
         <p:nvSpPr>
-          <p:cNvPr id="9" name="Text 7"/>
+          <p:cNvPr id="11" name="Text 8"/>
           <p:cNvSpPr/>
           <p:nvPr/>
         </p:nvSpPr>
@@ -7451,7 +7715,7 @@
       </p:sp>
       <p:sp>
         <p:nvSpPr>
-          <p:cNvPr id="10" name="Text 8"/>
+          <p:cNvPr id="12" name="Text 9"/>
           <p:cNvSpPr/>
           <p:nvPr/>
         </p:nvSpPr>
@@ -7504,7 +7768,7 @@
       </p:sp>
       <p:sp>
         <p:nvSpPr>
-          <p:cNvPr id="11" name="Shape 9"/>
+          <p:cNvPr id="13" name="Shape 10"/>
           <p:cNvSpPr/>
           <p:nvPr/>
         </p:nvSpPr>
@@ -7526,7 +7790,7 @@
       </p:sp>
       <p:sp>
         <p:nvSpPr>
-          <p:cNvPr id="12" name="Text 10"/>
+          <p:cNvPr id="14" name="Text 11"/>
           <p:cNvSpPr/>
           <p:nvPr/>
         </p:nvSpPr>
@@ -7565,7 +7829,7 @@
       </p:sp>
       <p:sp>
         <p:nvSpPr>
-          <p:cNvPr id="13" name="Text 11"/>
+          <p:cNvPr id="15" name="Text 12"/>
           <p:cNvSpPr/>
           <p:nvPr/>
         </p:nvSpPr>
@@ -7604,7 +7868,7 @@
       </p:sp>
       <p:sp>
         <p:nvSpPr>
-          <p:cNvPr id="14" name="Text 12"/>
+          <p:cNvPr id="16" name="Text 13"/>
           <p:cNvSpPr/>
           <p:nvPr/>
         </p:nvSpPr>
@@ -7646,7 +7910,7 @@
       </p:sp>
       <p:sp>
         <p:nvSpPr>
-          <p:cNvPr id="15" name="Text 13"/>
+          <p:cNvPr id="17" name="Text 14"/>
           <p:cNvSpPr/>
           <p:nvPr/>
         </p:nvSpPr>
@@ -7685,7 +7949,7 @@
       </p:sp>
       <p:sp>
         <p:nvSpPr>
-          <p:cNvPr id="16" name="Text 14"/>
+          <p:cNvPr id="18" name="Text 15"/>
           <p:cNvSpPr/>
           <p:nvPr/>
         </p:nvSpPr>
@@ -7724,7 +7988,7 @@
       </p:sp>
       <p:sp>
         <p:nvSpPr>
-          <p:cNvPr id="17" name="Text 15"/>
+          <p:cNvPr id="19" name="Text 16"/>
           <p:cNvSpPr/>
           <p:nvPr/>
         </p:nvSpPr>
@@ -7777,7 +8041,7 @@
       </p:sp>
       <p:sp>
         <p:nvSpPr>
-          <p:cNvPr id="18" name="Shape 16"/>
+          <p:cNvPr id="20" name="Shape 17"/>
           <p:cNvSpPr/>
           <p:nvPr/>
         </p:nvSpPr>
@@ -7799,7 +8063,7 @@
       </p:sp>
       <p:sp>
         <p:nvSpPr>
-          <p:cNvPr id="19" name="Text 17"/>
+          <p:cNvPr id="21" name="Text 18"/>
           <p:cNvSpPr/>
           <p:nvPr/>
         </p:nvSpPr>
@@ -7838,7 +8102,7 @@
       </p:sp>
       <p:sp>
         <p:nvSpPr>
-          <p:cNvPr id="20" name="Text 18"/>
+          <p:cNvPr id="22" name="Text 19"/>
           <p:cNvSpPr/>
           <p:nvPr/>
         </p:nvSpPr>
@@ -7877,7 +8141,7 @@
       </p:sp>
       <p:sp>
         <p:nvSpPr>
-          <p:cNvPr id="21" name="Text 19"/>
+          <p:cNvPr id="23" name="Text 20"/>
           <p:cNvSpPr/>
           <p:nvPr/>
         </p:nvSpPr>
@@ -7919,7 +8183,7 @@
       </p:sp>
       <p:sp>
         <p:nvSpPr>
-          <p:cNvPr id="22" name="Text 20"/>
+          <p:cNvPr id="24" name="Text 21"/>
           <p:cNvSpPr/>
           <p:nvPr/>
         </p:nvSpPr>
@@ -7958,7 +8222,7 @@
       </p:sp>
       <p:sp>
         <p:nvSpPr>
-          <p:cNvPr id="23" name="Text 21"/>
+          <p:cNvPr id="25" name="Text 22"/>
           <p:cNvSpPr/>
           <p:nvPr/>
         </p:nvSpPr>
@@ -7997,7 +8261,7 @@
       </p:sp>
       <p:sp>
         <p:nvSpPr>
-          <p:cNvPr id="24" name="Text 22"/>
+          <p:cNvPr id="26" name="Text 23"/>
           <p:cNvSpPr/>
           <p:nvPr/>
         </p:nvSpPr>
@@ -8050,7 +8314,7 @@
       </p:sp>
       <p:sp>
         <p:nvSpPr>
-          <p:cNvPr id="25" name="Text 23"/>
+          <p:cNvPr id="27" name="Text 24"/>
           <p:cNvSpPr/>
           <p:nvPr/>
         </p:nvSpPr>
@@ -8109,7 +8373,7 @@
       </p:sp>
       <p:sp>
         <p:nvSpPr>
-          <p:cNvPr id="26" name="Text 24"/>
+          <p:cNvPr id="28" name="Text 25"/>
           <p:cNvSpPr/>
           <p:nvPr/>
         </p:nvSpPr>
@@ -8168,7 +8432,7 @@
       </p:sp>
       <p:sp>
         <p:nvSpPr>
-          <p:cNvPr id="27" name="Text 25"/>
+          <p:cNvPr id="29" name="Text 26"/>
           <p:cNvSpPr/>
           <p:nvPr/>
         </p:nvSpPr>
@@ -8207,7 +8471,7 @@
       </p:sp>
       <p:sp>
         <p:nvSpPr>
-          <p:cNvPr id="28" name="Text 26"/>
+          <p:cNvPr id="30" name="Text 27"/>
           <p:cNvSpPr/>
           <p:nvPr/>
         </p:nvSpPr>
@@ -8278,14 +8542,58 @@
       </p:grpSpPr>
       <p:sp>
         <p:nvSpPr>
-          <p:cNvPr id="2" name="Text 0"/>
-          <p:cNvSpPr/>
-          <p:nvPr/>
-        </p:nvSpPr>
-        <p:spPr>
-          <a:xfrm>
-            <a:off x="548640" y="384048"/>
-            <a:ext cx="11091672" cy="320040"/>
+          <p:cNvPr id="2" name="Shape 0"/>
+          <p:cNvSpPr/>
+          <p:nvPr/>
+        </p:nvSpPr>
+        <p:spPr>
+          <a:xfrm>
+            <a:off x="548640" y="365760"/>
+            <a:ext cx="365760" cy="365760"/>
+          </a:xfrm>
+          <a:prstGeom prst="ellipse">
+            <a:avLst/>
+          </a:prstGeom>
+          <a:solidFill>
+            <a:srgbClr val="1E2761"/>
+          </a:solidFill>
+          <a:ln/>
+        </p:spPr>
+      </p:sp>
+      <p:pic>
+        <p:nvPicPr>
+          <p:cNvPr id="3" name="Image 0" descr="preencoded.png">    </p:cNvPr>
+          <p:cNvPicPr>
+            <a:picLocks noChangeAspect="1"/>
+          </p:cNvPicPr>
+          <p:nvPr/>
+        </p:nvPicPr>
+        <p:blipFill>
+          <a:blip r:embed="rId1"/>
+          <a:stretch>
+            <a:fillRect/>
+          </a:stretch>
+        </p:blipFill>
+        <p:spPr>
+          <a:xfrm>
+            <a:off x="649224" y="466344"/>
+            <a:ext cx="164592" cy="164592"/>
+          </a:xfrm>
+          <a:prstGeom prst="rect">
+            <a:avLst/>
+          </a:prstGeom>
+        </p:spPr>
+      </p:pic>
+      <p:sp>
+        <p:nvSpPr>
+          <p:cNvPr id="4" name="Text 1"/>
+          <p:cNvSpPr/>
+          <p:nvPr/>
+        </p:nvSpPr>
+        <p:spPr>
+          <a:xfrm>
+            <a:off x="1051560" y="384048"/>
+            <a:ext cx="10588752" cy="320040"/>
           </a:xfrm>
           <a:prstGeom prst="rect">
             <a:avLst/>
@@ -8317,7 +8625,7 @@
       </p:sp>
       <p:sp>
         <p:nvSpPr>
-          <p:cNvPr id="3" name="Text 1"/>
+          <p:cNvPr id="5" name="Text 2"/>
           <p:cNvSpPr/>
           <p:nvPr/>
         </p:nvSpPr>
@@ -8356,7 +8664,7 @@
       </p:sp>
       <p:sp>
         <p:nvSpPr>
-          <p:cNvPr id="4" name="Shape 2"/>
+          <p:cNvPr id="6" name="Shape 3"/>
           <p:cNvSpPr/>
           <p:nvPr/>
         </p:nvSpPr>
@@ -8378,7 +8686,7 @@
       </p:sp>
       <p:sp>
         <p:nvSpPr>
-          <p:cNvPr id="5" name="Text 3"/>
+          <p:cNvPr id="7" name="Text 4"/>
           <p:cNvSpPr/>
           <p:nvPr/>
         </p:nvSpPr>
@@ -8417,7 +8725,7 @@
       </p:sp>
       <p:sp>
         <p:nvSpPr>
-          <p:cNvPr id="6" name="Text 4"/>
+          <p:cNvPr id="8" name="Text 5"/>
           <p:cNvSpPr/>
           <p:nvPr/>
         </p:nvSpPr>
@@ -8456,7 +8764,7 @@
       </p:sp>
       <p:sp>
         <p:nvSpPr>
-          <p:cNvPr id="7" name="Text 5"/>
+          <p:cNvPr id="9" name="Text 6"/>
           <p:cNvSpPr/>
           <p:nvPr/>
         </p:nvSpPr>
@@ -8495,7 +8803,7 @@
       </p:sp>
       <p:sp>
         <p:nvSpPr>
-          <p:cNvPr id="8" name="Shape 6"/>
+          <p:cNvPr id="10" name="Shape 7"/>
           <p:cNvSpPr/>
           <p:nvPr/>
         </p:nvSpPr>
@@ -8517,7 +8825,7 @@
       </p:sp>
       <p:sp>
         <p:nvSpPr>
-          <p:cNvPr id="9" name="Text 7"/>
+          <p:cNvPr id="11" name="Text 8"/>
           <p:cNvSpPr/>
           <p:nvPr/>
         </p:nvSpPr>
@@ -8556,7 +8864,7 @@
       </p:sp>
       <p:sp>
         <p:nvSpPr>
-          <p:cNvPr id="10" name="Text 8"/>
+          <p:cNvPr id="12" name="Text 9"/>
           <p:cNvSpPr/>
           <p:nvPr/>
         </p:nvSpPr>
@@ -8595,7 +8903,7 @@
       </p:sp>
       <p:sp>
         <p:nvSpPr>
-          <p:cNvPr id="11" name="Text 9"/>
+          <p:cNvPr id="13" name="Text 10"/>
           <p:cNvSpPr/>
           <p:nvPr/>
         </p:nvSpPr>
@@ -8634,7 +8942,7 @@
       </p:sp>
       <p:sp>
         <p:nvSpPr>
-          <p:cNvPr id="12" name="Shape 10"/>
+          <p:cNvPr id="14" name="Shape 11"/>
           <p:cNvSpPr/>
           <p:nvPr/>
         </p:nvSpPr>
@@ -8656,7 +8964,7 @@
       </p:sp>
       <p:sp>
         <p:nvSpPr>
-          <p:cNvPr id="13" name="Text 11"/>
+          <p:cNvPr id="15" name="Text 12"/>
           <p:cNvSpPr/>
           <p:nvPr/>
         </p:nvSpPr>
@@ -8695,7 +9003,7 @@
       </p:sp>
       <p:sp>
         <p:nvSpPr>
-          <p:cNvPr id="14" name="Text 12"/>
+          <p:cNvPr id="16" name="Text 13"/>
           <p:cNvSpPr/>
           <p:nvPr/>
         </p:nvSpPr>
@@ -8734,7 +9042,7 @@
       </p:sp>
       <p:sp>
         <p:nvSpPr>
-          <p:cNvPr id="15" name="Text 13"/>
+          <p:cNvPr id="17" name="Text 14"/>
           <p:cNvSpPr/>
           <p:nvPr/>
         </p:nvSpPr>
@@ -8773,7 +9081,7 @@
       </p:sp>
       <p:sp>
         <p:nvSpPr>
-          <p:cNvPr id="16" name="Text 14"/>
+          <p:cNvPr id="18" name="Text 15"/>
           <p:cNvSpPr/>
           <p:nvPr/>
         </p:nvSpPr>
@@ -8812,7 +9120,7 @@
       </p:sp>
       <p:sp>
         <p:nvSpPr>
-          <p:cNvPr id="17" name="Shape 15"/>
+          <p:cNvPr id="19" name="Shape 16"/>
           <p:cNvSpPr/>
           <p:nvPr/>
         </p:nvSpPr>
@@ -8834,7 +9142,7 @@
       </p:sp>
       <p:sp>
         <p:nvSpPr>
-          <p:cNvPr id="18" name="Text 16"/>
+          <p:cNvPr id="20" name="Text 17"/>
           <p:cNvSpPr/>
           <p:nvPr/>
         </p:nvSpPr>
@@ -8873,7 +9181,7 @@
       </p:sp>
       <p:sp>
         <p:nvSpPr>
-          <p:cNvPr id="19" name="Text 17"/>
+          <p:cNvPr id="21" name="Text 18"/>
           <p:cNvSpPr/>
           <p:nvPr/>
         </p:nvSpPr>
@@ -8912,7 +9220,7 @@
       </p:sp>
       <p:sp>
         <p:nvSpPr>
-          <p:cNvPr id="20" name="Shape 18"/>
+          <p:cNvPr id="22" name="Shape 19"/>
           <p:cNvSpPr/>
           <p:nvPr/>
         </p:nvSpPr>
@@ -8934,7 +9242,7 @@
       </p:sp>
       <p:sp>
         <p:nvSpPr>
-          <p:cNvPr id="21" name="Text 19"/>
+          <p:cNvPr id="23" name="Text 20"/>
           <p:cNvSpPr/>
           <p:nvPr/>
         </p:nvSpPr>
@@ -8973,7 +9281,7 @@
       </p:sp>
       <p:sp>
         <p:nvSpPr>
-          <p:cNvPr id="22" name="Text 20"/>
+          <p:cNvPr id="24" name="Text 21"/>
           <p:cNvSpPr/>
           <p:nvPr/>
         </p:nvSpPr>
@@ -9012,7 +9320,7 @@
       </p:sp>
       <p:sp>
         <p:nvSpPr>
-          <p:cNvPr id="23" name="Shape 21"/>
+          <p:cNvPr id="25" name="Shape 22"/>
           <p:cNvSpPr/>
           <p:nvPr/>
         </p:nvSpPr>
@@ -9034,7 +9342,7 @@
       </p:sp>
       <p:sp>
         <p:nvSpPr>
-          <p:cNvPr id="24" name="Text 22"/>
+          <p:cNvPr id="26" name="Text 23"/>
           <p:cNvSpPr/>
           <p:nvPr/>
         </p:nvSpPr>
@@ -9073,7 +9381,7 @@
       </p:sp>
       <p:sp>
         <p:nvSpPr>
-          <p:cNvPr id="25" name="Text 23"/>
+          <p:cNvPr id="27" name="Text 24"/>
           <p:cNvSpPr/>
           <p:nvPr/>
         </p:nvSpPr>
@@ -9112,7 +9420,7 @@
       </p:sp>
       <p:sp>
         <p:nvSpPr>
-          <p:cNvPr id="26" name="Shape 24"/>
+          <p:cNvPr id="28" name="Shape 25"/>
           <p:cNvSpPr/>
           <p:nvPr/>
         </p:nvSpPr>
@@ -9134,7 +9442,7 @@
       </p:sp>
       <p:sp>
         <p:nvSpPr>
-          <p:cNvPr id="27" name="Text 25"/>
+          <p:cNvPr id="29" name="Text 26"/>
           <p:cNvSpPr/>
           <p:nvPr/>
         </p:nvSpPr>
@@ -9173,7 +9481,7 @@
       </p:sp>
       <p:sp>
         <p:nvSpPr>
-          <p:cNvPr id="28" name="Text 26"/>
+          <p:cNvPr id="30" name="Text 27"/>
           <p:cNvSpPr/>
           <p:nvPr/>
         </p:nvSpPr>
@@ -9212,7 +9520,7 @@
       </p:sp>
       <p:sp>
         <p:nvSpPr>
-          <p:cNvPr id="29" name="Shape 27"/>
+          <p:cNvPr id="31" name="Shape 28"/>
           <p:cNvSpPr/>
           <p:nvPr/>
         </p:nvSpPr>
@@ -9234,7 +9542,7 @@
       </p:sp>
       <p:sp>
         <p:nvSpPr>
-          <p:cNvPr id="30" name="Text 28"/>
+          <p:cNvPr id="32" name="Text 29"/>
           <p:cNvSpPr/>
           <p:nvPr/>
         </p:nvSpPr>
@@ -9273,7 +9581,7 @@
       </p:sp>
       <p:sp>
         <p:nvSpPr>
-          <p:cNvPr id="31" name="Text 29"/>
+          <p:cNvPr id="33" name="Text 30"/>
           <p:cNvSpPr/>
           <p:nvPr/>
         </p:nvSpPr>
@@ -9312,7 +9620,7 @@
       </p:sp>
       <p:sp>
         <p:nvSpPr>
-          <p:cNvPr id="32" name="Text 30"/>
+          <p:cNvPr id="34" name="Text 31"/>
           <p:cNvSpPr/>
           <p:nvPr/>
         </p:nvSpPr>
@@ -9383,14 +9691,58 @@
       </p:grpSpPr>
       <p:sp>
         <p:nvSpPr>
-          <p:cNvPr id="2" name="Text 0"/>
-          <p:cNvSpPr/>
-          <p:nvPr/>
-        </p:nvSpPr>
-        <p:spPr>
-          <a:xfrm>
-            <a:off x="548640" y="384048"/>
-            <a:ext cx="11091672" cy="320040"/>
+          <p:cNvPr id="2" name="Shape 0"/>
+          <p:cNvSpPr/>
+          <p:nvPr/>
+        </p:nvSpPr>
+        <p:spPr>
+          <a:xfrm>
+            <a:off x="548640" y="365760"/>
+            <a:ext cx="365760" cy="365760"/>
+          </a:xfrm>
+          <a:prstGeom prst="ellipse">
+            <a:avLst/>
+          </a:prstGeom>
+          <a:solidFill>
+            <a:srgbClr val="1E2761"/>
+          </a:solidFill>
+          <a:ln/>
+        </p:spPr>
+      </p:sp>
+      <p:pic>
+        <p:nvPicPr>
+          <p:cNvPr id="3" name="Image 0" descr="preencoded.png">    </p:cNvPr>
+          <p:cNvPicPr>
+            <a:picLocks noChangeAspect="1"/>
+          </p:cNvPicPr>
+          <p:nvPr/>
+        </p:nvPicPr>
+        <p:blipFill>
+          <a:blip r:embed="rId1"/>
+          <a:stretch>
+            <a:fillRect/>
+          </a:stretch>
+        </p:blipFill>
+        <p:spPr>
+          <a:xfrm>
+            <a:off x="649224" y="466344"/>
+            <a:ext cx="164592" cy="164592"/>
+          </a:xfrm>
+          <a:prstGeom prst="rect">
+            <a:avLst/>
+          </a:prstGeom>
+        </p:spPr>
+      </p:pic>
+      <p:sp>
+        <p:nvSpPr>
+          <p:cNvPr id="4" name="Text 1"/>
+          <p:cNvSpPr/>
+          <p:nvPr/>
+        </p:nvSpPr>
+        <p:spPr>
+          <a:xfrm>
+            <a:off x="1051560" y="384048"/>
+            <a:ext cx="10588752" cy="320040"/>
           </a:xfrm>
           <a:prstGeom prst="rect">
             <a:avLst/>
@@ -9422,7 +9774,7 @@
       </p:sp>
       <p:sp>
         <p:nvSpPr>
-          <p:cNvPr id="3" name="Text 1"/>
+          <p:cNvPr id="5" name="Text 2"/>
           <p:cNvSpPr/>
           <p:nvPr/>
         </p:nvSpPr>
@@ -10862,7 +11214,7 @@
       </p:graphicFrame>
       <p:sp>
         <p:nvSpPr>
-          <p:cNvPr id="5" name="Text 2"/>
+          <p:cNvPr id="7" name="Text 3"/>
           <p:cNvSpPr/>
           <p:nvPr/>
         </p:nvSpPr>
@@ -10901,7 +11253,7 @@
       </p:sp>
       <p:sp>
         <p:nvSpPr>
-          <p:cNvPr id="6" name="Shape 3"/>
+          <p:cNvPr id="8" name="Shape 4"/>
           <p:cNvSpPr/>
           <p:nvPr/>
         </p:nvSpPr>
@@ -10923,7 +11275,7 @@
       </p:sp>
       <p:sp>
         <p:nvSpPr>
-          <p:cNvPr id="7" name="Text 4"/>
+          <p:cNvPr id="9" name="Text 5"/>
           <p:cNvSpPr/>
           <p:nvPr/>
         </p:nvSpPr>
@@ -10962,7 +11314,7 @@
       </p:sp>
       <p:sp>
         <p:nvSpPr>
-          <p:cNvPr id="8" name="Text 5"/>
+          <p:cNvPr id="10" name="Text 6"/>
           <p:cNvSpPr/>
           <p:nvPr/>
         </p:nvSpPr>
@@ -11001,7 +11353,7 @@
       </p:sp>
       <p:sp>
         <p:nvSpPr>
-          <p:cNvPr id="9" name="Text 6"/>
+          <p:cNvPr id="11" name="Text 7"/>
           <p:cNvSpPr/>
           <p:nvPr/>
         </p:nvSpPr>
@@ -11040,7 +11392,7 @@
       </p:sp>
       <p:sp>
         <p:nvSpPr>
-          <p:cNvPr id="10" name="Text 7"/>
+          <p:cNvPr id="12" name="Text 8"/>
           <p:cNvSpPr/>
           <p:nvPr/>
         </p:nvSpPr>
@@ -11079,7 +11431,7 @@
       </p:sp>
       <p:sp>
         <p:nvSpPr>
-          <p:cNvPr id="11" name="Text 8"/>
+          <p:cNvPr id="13" name="Text 9"/>
           <p:cNvSpPr/>
           <p:nvPr/>
         </p:nvSpPr>
@@ -11118,7 +11470,7 @@
       </p:sp>
       <p:sp>
         <p:nvSpPr>
-          <p:cNvPr id="12" name="Text 9"/>
+          <p:cNvPr id="14" name="Text 10"/>
           <p:cNvSpPr/>
           <p:nvPr/>
         </p:nvSpPr>
@@ -11157,7 +11509,7 @@
       </p:sp>
       <p:sp>
         <p:nvSpPr>
-          <p:cNvPr id="13" name="Text 10"/>
+          <p:cNvPr id="15" name="Text 11"/>
           <p:cNvSpPr/>
           <p:nvPr/>
         </p:nvSpPr>
@@ -11196,7 +11548,7 @@
       </p:sp>
       <p:sp>
         <p:nvSpPr>
-          <p:cNvPr id="14" name="Text 11"/>
+          <p:cNvPr id="16" name="Text 12"/>
           <p:cNvSpPr/>
           <p:nvPr/>
         </p:nvSpPr>
@@ -11238,7 +11590,7 @@
       </p:sp>
       <p:sp>
         <p:nvSpPr>
-          <p:cNvPr id="15" name="Text 12"/>
+          <p:cNvPr id="17" name="Text 13"/>
           <p:cNvSpPr/>
           <p:nvPr/>
         </p:nvSpPr>
@@ -11309,14 +11661,58 @@
       </p:grpSpPr>
       <p:sp>
         <p:nvSpPr>
-          <p:cNvPr id="2" name="Text 0"/>
-          <p:cNvSpPr/>
-          <p:nvPr/>
-        </p:nvSpPr>
-        <p:spPr>
-          <a:xfrm>
-            <a:off x="548640" y="384048"/>
-            <a:ext cx="11091672" cy="320040"/>
+          <p:cNvPr id="2" name="Shape 0"/>
+          <p:cNvSpPr/>
+          <p:nvPr/>
+        </p:nvSpPr>
+        <p:spPr>
+          <a:xfrm>
+            <a:off x="548640" y="365760"/>
+            <a:ext cx="365760" cy="365760"/>
+          </a:xfrm>
+          <a:prstGeom prst="ellipse">
+            <a:avLst/>
+          </a:prstGeom>
+          <a:solidFill>
+            <a:srgbClr val="1E2761"/>
+          </a:solidFill>
+          <a:ln/>
+        </p:spPr>
+      </p:sp>
+      <p:pic>
+        <p:nvPicPr>
+          <p:cNvPr id="3" name="Image 0" descr="preencoded.png">    </p:cNvPr>
+          <p:cNvPicPr>
+            <a:picLocks noChangeAspect="1"/>
+          </p:cNvPicPr>
+          <p:nvPr/>
+        </p:nvPicPr>
+        <p:blipFill>
+          <a:blip r:embed="rId1"/>
+          <a:stretch>
+            <a:fillRect/>
+          </a:stretch>
+        </p:blipFill>
+        <p:spPr>
+          <a:xfrm>
+            <a:off x="649224" y="466344"/>
+            <a:ext cx="164592" cy="164592"/>
+          </a:xfrm>
+          <a:prstGeom prst="rect">
+            <a:avLst/>
+          </a:prstGeom>
+        </p:spPr>
+      </p:pic>
+      <p:sp>
+        <p:nvSpPr>
+          <p:cNvPr id="4" name="Text 1"/>
+          <p:cNvSpPr/>
+          <p:nvPr/>
+        </p:nvSpPr>
+        <p:spPr>
+          <a:xfrm>
+            <a:off x="1051560" y="384048"/>
+            <a:ext cx="10588752" cy="320040"/>
           </a:xfrm>
           <a:prstGeom prst="rect">
             <a:avLst/>
@@ -11348,7 +11744,7 @@
       </p:sp>
       <p:sp>
         <p:nvSpPr>
-          <p:cNvPr id="3" name="Text 1"/>
+          <p:cNvPr id="5" name="Text 2"/>
           <p:cNvSpPr/>
           <p:nvPr/>
         </p:nvSpPr>
@@ -11387,7 +11783,7 @@
       </p:sp>
       <p:graphicFrame>
         <p:nvGraphicFramePr>
-          <p:cNvPr id="4" name="Chart 0" descr=""/>
+          <p:cNvPr id="6" name="Chart 0" descr=""/>
           <p:cNvGraphicFramePr/>
           <p:nvPr/>
         </p:nvGraphicFramePr>
@@ -11397,13 +11793,13 @@
         </p:xfrm>
         <a:graphic xmlns:a="http://schemas.openxmlformats.org/drawingml/2006/main">
           <a:graphicData uri="http://schemas.openxmlformats.org/drawingml/2006/chart">
-            <c:chart xmlns:c="http://schemas.openxmlformats.org/drawingml/2006/chart" r:id="rId1"/>
+            <c:chart xmlns:c="http://schemas.openxmlformats.org/drawingml/2006/chart" r:id="rId2"/>
           </a:graphicData>
         </a:graphic>
       </p:graphicFrame>
       <p:sp>
         <p:nvSpPr>
-          <p:cNvPr id="5" name="Shape 2"/>
+          <p:cNvPr id="7" name="Shape 3"/>
           <p:cNvSpPr/>
           <p:nvPr/>
         </p:nvSpPr>
@@ -11425,7 +11821,7 @@
       </p:sp>
       <p:sp>
         <p:nvSpPr>
-          <p:cNvPr id="6" name="Text 3"/>
+          <p:cNvPr id="8" name="Text 4"/>
           <p:cNvSpPr/>
           <p:nvPr/>
         </p:nvSpPr>
@@ -11464,7 +11860,7 @@
       </p:sp>
       <p:sp>
         <p:nvSpPr>
-          <p:cNvPr id="7" name="Text 4"/>
+          <p:cNvPr id="9" name="Text 5"/>
           <p:cNvSpPr/>
           <p:nvPr/>
         </p:nvSpPr>
@@ -11498,7 +11894,7 @@
                 <a:ea typeface="Calibri" pitchFamily="34" charset="-122"/>
                 <a:cs typeface="Calibri" pitchFamily="34" charset="-120"/>
               </a:rPr>
-              <a:t>Baseline CNN's AUC-ROC on OpenI — barely above the 0.5 coin-flip line.</a:t>
+              <a:t>Baseline CNN's AUC-ROC on OpenI — 95% CI 0.469–0.556, straddling chance.</a:t>
             </a:r>
             <a:endParaRPr lang="en-US" sz="1300" dirty="0"/>
           </a:p>
@@ -11506,7 +11902,7 @@
       </p:sp>
       <p:sp>
         <p:nvSpPr>
-          <p:cNvPr id="8" name="Text 5"/>
+          <p:cNvPr id="10" name="Text 6"/>
           <p:cNvSpPr/>
           <p:nvPr/>
         </p:nvSpPr>
@@ -11545,7 +11941,7 @@
       </p:sp>
       <p:sp>
         <p:nvSpPr>
-          <p:cNvPr id="9" name="Text 6"/>
+          <p:cNvPr id="11" name="Text 7"/>
           <p:cNvSpPr/>
           <p:nvPr/>
         </p:nvSpPr>
@@ -11587,7 +11983,7 @@
       </p:sp>
       <p:sp>
         <p:nvSpPr>
-          <p:cNvPr id="10" name="Text 7"/>
+          <p:cNvPr id="12" name="Text 8"/>
           <p:cNvSpPr/>
           <p:nvPr/>
         </p:nvSpPr>
@@ -11658,14 +12054,58 @@
       </p:grpSpPr>
       <p:sp>
         <p:nvSpPr>
-          <p:cNvPr id="2" name="Text 0"/>
-          <p:cNvSpPr/>
-          <p:nvPr/>
-        </p:nvSpPr>
-        <p:spPr>
-          <a:xfrm>
-            <a:off x="548640" y="384048"/>
-            <a:ext cx="11091672" cy="320040"/>
+          <p:cNvPr id="2" name="Shape 0"/>
+          <p:cNvSpPr/>
+          <p:nvPr/>
+        </p:nvSpPr>
+        <p:spPr>
+          <a:xfrm>
+            <a:off x="548640" y="365760"/>
+            <a:ext cx="365760" cy="365760"/>
+          </a:xfrm>
+          <a:prstGeom prst="ellipse">
+            <a:avLst/>
+          </a:prstGeom>
+          <a:solidFill>
+            <a:srgbClr val="1E2761"/>
+          </a:solidFill>
+          <a:ln/>
+        </p:spPr>
+      </p:sp>
+      <p:pic>
+        <p:nvPicPr>
+          <p:cNvPr id="3" name="Image 0" descr="preencoded.png">    </p:cNvPr>
+          <p:cNvPicPr>
+            <a:picLocks noChangeAspect="1"/>
+          </p:cNvPicPr>
+          <p:nvPr/>
+        </p:nvPicPr>
+        <p:blipFill>
+          <a:blip r:embed="rId1"/>
+          <a:stretch>
+            <a:fillRect/>
+          </a:stretch>
+        </p:blipFill>
+        <p:spPr>
+          <a:xfrm>
+            <a:off x="649224" y="466344"/>
+            <a:ext cx="164592" cy="164592"/>
+          </a:xfrm>
+          <a:prstGeom prst="rect">
+            <a:avLst/>
+          </a:prstGeom>
+        </p:spPr>
+      </p:pic>
+      <p:sp>
+        <p:nvSpPr>
+          <p:cNvPr id="4" name="Text 1"/>
+          <p:cNvSpPr/>
+          <p:nvPr/>
+        </p:nvSpPr>
+        <p:spPr>
+          <a:xfrm>
+            <a:off x="1051560" y="384048"/>
+            <a:ext cx="10588752" cy="320040"/>
           </a:xfrm>
           <a:prstGeom prst="rect">
             <a:avLst/>
@@ -11697,7 +12137,7 @@
       </p:sp>
       <p:sp>
         <p:nvSpPr>
-          <p:cNvPr id="3" name="Text 1"/>
+          <p:cNvPr id="5" name="Text 2"/>
           <p:cNvSpPr/>
           <p:nvPr/>
         </p:nvSpPr>
@@ -11736,7 +12176,7 @@
       </p:sp>
       <p:sp>
         <p:nvSpPr>
-          <p:cNvPr id="4" name="Shape 2"/>
+          <p:cNvPr id="6" name="Shape 3"/>
           <p:cNvSpPr/>
           <p:nvPr/>
         </p:nvSpPr>
@@ -11758,7 +12198,7 @@
       </p:sp>
       <p:sp>
         <p:nvSpPr>
-          <p:cNvPr id="5" name="Text 3"/>
+          <p:cNvPr id="7" name="Text 4"/>
           <p:cNvSpPr/>
           <p:nvPr/>
         </p:nvSpPr>
@@ -11797,7 +12237,7 @@
       </p:sp>
       <p:sp>
         <p:nvSpPr>
-          <p:cNvPr id="6" name="Text 4"/>
+          <p:cNvPr id="8" name="Text 5"/>
           <p:cNvSpPr/>
           <p:nvPr/>
         </p:nvSpPr>
@@ -11839,7 +12279,7 @@
       </p:sp>
       <p:sp>
         <p:nvSpPr>
-          <p:cNvPr id="7" name="Text 5"/>
+          <p:cNvPr id="9" name="Text 6"/>
           <p:cNvSpPr/>
           <p:nvPr/>
         </p:nvSpPr>
@@ -11878,7 +12318,7 @@
       </p:sp>
       <p:sp>
         <p:nvSpPr>
-          <p:cNvPr id="8" name="Shape 6"/>
+          <p:cNvPr id="10" name="Shape 7"/>
           <p:cNvSpPr/>
           <p:nvPr/>
         </p:nvSpPr>
@@ -11900,7 +12340,7 @@
       </p:sp>
       <p:sp>
         <p:nvSpPr>
-          <p:cNvPr id="9" name="Text 7"/>
+          <p:cNvPr id="11" name="Text 8"/>
           <p:cNvSpPr/>
           <p:nvPr/>
         </p:nvSpPr>
@@ -11939,7 +12379,7 @@
       </p:sp>
       <p:sp>
         <p:nvSpPr>
-          <p:cNvPr id="10" name="Text 8"/>
+          <p:cNvPr id="12" name="Text 9"/>
           <p:cNvSpPr/>
           <p:nvPr/>
         </p:nvSpPr>
@@ -11981,7 +12421,7 @@
       </p:sp>
       <p:sp>
         <p:nvSpPr>
-          <p:cNvPr id="11" name="Text 9"/>
+          <p:cNvPr id="13" name="Text 10"/>
           <p:cNvSpPr/>
           <p:nvPr/>
         </p:nvSpPr>
@@ -12020,7 +12460,7 @@
       </p:sp>
       <p:sp>
         <p:nvSpPr>
-          <p:cNvPr id="12" name="Text 10"/>
+          <p:cNvPr id="14" name="Text 11"/>
           <p:cNvSpPr/>
           <p:nvPr/>
         </p:nvSpPr>
@@ -12059,7 +12499,7 @@
       </p:sp>
       <p:sp>
         <p:nvSpPr>
-          <p:cNvPr id="13" name="Text 11"/>
+          <p:cNvPr id="15" name="Text 12"/>
           <p:cNvSpPr/>
           <p:nvPr/>
         </p:nvSpPr>
@@ -12098,7 +12538,7 @@
       </p:sp>
       <p:sp>
         <p:nvSpPr>
-          <p:cNvPr id="14" name="Shape 12"/>
+          <p:cNvPr id="16" name="Shape 13"/>
           <p:cNvSpPr/>
           <p:nvPr/>
         </p:nvSpPr>
@@ -12120,7 +12560,7 @@
       </p:sp>
       <p:sp>
         <p:nvSpPr>
-          <p:cNvPr id="15" name="Text 13"/>
+          <p:cNvPr id="17" name="Text 14"/>
           <p:cNvSpPr/>
           <p:nvPr/>
         </p:nvSpPr>
@@ -12159,7 +12599,7 @@
       </p:sp>
       <p:sp>
         <p:nvSpPr>
-          <p:cNvPr id="16" name="Text 14"/>
+          <p:cNvPr id="18" name="Text 15"/>
           <p:cNvSpPr/>
           <p:nvPr/>
         </p:nvSpPr>
@@ -12198,7 +12638,7 @@
       </p:sp>
       <p:sp>
         <p:nvSpPr>
-          <p:cNvPr id="17" name="Shape 15"/>
+          <p:cNvPr id="19" name="Shape 16"/>
           <p:cNvSpPr/>
           <p:nvPr/>
         </p:nvSpPr>
@@ -12220,7 +12660,7 @@
       </p:sp>
       <p:sp>
         <p:nvSpPr>
-          <p:cNvPr id="18" name="Text 16"/>
+          <p:cNvPr id="20" name="Text 17"/>
           <p:cNvSpPr/>
           <p:nvPr/>
         </p:nvSpPr>
@@ -12259,7 +12699,7 @@
       </p:sp>
       <p:sp>
         <p:nvSpPr>
-          <p:cNvPr id="19" name="Text 17"/>
+          <p:cNvPr id="21" name="Text 18"/>
           <p:cNvSpPr/>
           <p:nvPr/>
         </p:nvSpPr>
@@ -12298,7 +12738,7 @@
       </p:sp>
       <p:sp>
         <p:nvSpPr>
-          <p:cNvPr id="20" name="Shape 18"/>
+          <p:cNvPr id="22" name="Shape 19"/>
           <p:cNvSpPr/>
           <p:nvPr/>
         </p:nvSpPr>
@@ -12320,7 +12760,7 @@
       </p:sp>
       <p:sp>
         <p:nvSpPr>
-          <p:cNvPr id="21" name="Text 19"/>
+          <p:cNvPr id="23" name="Text 20"/>
           <p:cNvSpPr/>
           <p:nvPr/>
         </p:nvSpPr>
@@ -12359,7 +12799,7 @@
       </p:sp>
       <p:sp>
         <p:nvSpPr>
-          <p:cNvPr id="22" name="Text 20"/>
+          <p:cNvPr id="24" name="Text 21"/>
           <p:cNvSpPr/>
           <p:nvPr/>
         </p:nvSpPr>

</xml_diff>

<commit_message>
Add closing Q&A slide to presentation
</commit_message>
<xml_diff>
--- a/docs/presentation.pptx
+++ b/docs/presentation.pptx
@@ -18,9 +18,10 @@
     <p:sldId id="266" r:id="rId12"/>
     <p:sldId id="267" r:id="rId13"/>
     <p:sldId id="268" r:id="rId14"/>
+    <p:sldId id="269" r:id="rId15"/>
   </p:sldIdLst>
   <p:notesMasterIdLst>
-    <p:notesMasterId r:id="rId15"/>
+    <p:notesMasterId r:id="rId16"/>
   </p:notesMasterIdLst>
   <p:sldSz cx="12192000" cy="6858000"/>
   <p:notesSz cx="6858000" cy="12192000"/>
@@ -1321,7 +1322,7 @@
           <a:p>
             <a:r>
               <a:rPr lang="en-US" dirty="0"/>
-              <a:t>So: transfer learning wins in-domain, decisively. But that in-domain edge doesn't buy trustworthy generalization -- all three models fail non-uniformly outside their training distribution, and where we can explain that failure statistically, it's resolution and detected artifacts, not an unexplained domain-shift or age label. That's the difference between a black-box excuse and a testable, actionable finding -- and a concrete argument against single-site validation as grounds for clinical deployment. Thank you.</a:t>
+              <a:t>So: transfer learning wins in-domain, decisively. But that in-domain edge doesn't buy trustworthy generalization -- all three models fail non-uniformly outside their training distribution, and where we can explain that failure statistically, it's resolution and detected artifacts, not an unexplained domain-shift or age label. That's the difference between a black-box excuse and a testable, actionable finding -- and a concrete argument against single-site validation as grounds for clinical deployment.</a:t>
             </a:r>
             <a:endParaRPr lang="en-US" dirty="0"/>
           </a:p>
@@ -1345,6 +1346,94 @@
             <a:fld id="{F7021451-1387-4CA6-816F-3879F97B5CBC}" type="slidenum">
               <a:rPr lang="en-US"/>
               <a:t>13</a:t>
+            </a:fld>
+            <a:endParaRPr lang="en-US"/>
+          </a:p>
+        </p:txBody>
+      </p:sp>
+    </p:spTree>
+    <p:extLst>
+      <p:ext uri="{BB962C8B-B14F-4D97-AF65-F5344CB8AC3E}">
+        <p14:creationId xmlns:p14="http://schemas.microsoft.com/office/powerpoint/2010/main" val="1024086991"/>
+      </p:ext>
+    </p:extLst>
+  </p:cSld>
+  <p:clrMapOvr>
+    <a:masterClrMapping/>
+  </p:clrMapOvr>
+</p:notes>
+</file>
+
+<file path=ppt/notesSlides/notesSlide14.xml><?xml version="1.0" encoding="utf-8"?>
+<p:notes xmlns:a="http://schemas.openxmlformats.org/drawingml/2006/main" xmlns:r="http://schemas.openxmlformats.org/officeDocument/2006/relationships" xmlns:p="http://schemas.openxmlformats.org/presentationml/2006/main">
+  <p:cSld>
+    <p:spTree>
+      <p:nvGrpSpPr>
+        <p:cNvPr id="1" name=""/>
+        <p:cNvGrpSpPr/>
+        <p:nvPr/>
+      </p:nvGrpSpPr>
+      <p:grpSpPr>
+        <a:xfrm>
+          <a:off x="0" y="0"/>
+          <a:ext cx="0" cy="0"/>
+          <a:chOff x="0" y="0"/>
+          <a:chExt cx="0" cy="0"/>
+        </a:xfrm>
+      </p:grpSpPr>
+      <p:sp>
+        <p:nvSpPr>
+          <p:cNvPr id="2" name="Slide Image Placeholder 1"/>
+          <p:cNvSpPr>
+            <a:spLocks noGrp="1" noRot="1" noChangeAspect="1"/>
+          </p:cNvSpPr>
+          <p:nvPr>
+            <p:ph type="sldImg"/>
+          </p:nvPr>
+        </p:nvSpPr>
+        <p:spPr/>
+      </p:sp>
+      <p:sp>
+        <p:nvSpPr>
+          <p:cNvPr id="3" name="Notes Placeholder 2"/>
+          <p:cNvSpPr>
+            <a:spLocks noGrp="1"/>
+          </p:cNvSpPr>
+          <p:nvPr>
+            <p:ph type="body" idx="1"/>
+          </p:nvPr>
+        </p:nvSpPr>
+        <p:spPr/>
+        <p:txBody>
+          <a:bodyPr/>
+          <a:lstStyle/>
+          <a:p>
+            <a:r>
+              <a:rPr lang="en-US" dirty="0"/>
+              <a:t>Thank you for your time. I've left a few open questions on the slide that I'd genuinely like your take on -- particularly around where a deployment threshold should sit, and what evidence would change the causal-analysis conclusion. Happy to go deeper into any part of the methodology or the code itself.</a:t>
+            </a:r>
+            <a:endParaRPr lang="en-US" dirty="0"/>
+          </a:p>
+        </p:txBody>
+      </p:sp>
+      <p:sp>
+        <p:nvSpPr>
+          <p:cNvPr id="4" name="Slide Number Placeholder 3"/>
+          <p:cNvSpPr>
+            <a:spLocks noGrp="1"/>
+          </p:cNvSpPr>
+          <p:nvPr>
+            <p:ph type="sldNum" sz="quarter" idx="10"/>
+          </p:nvPr>
+        </p:nvSpPr>
+        <p:spPr/>
+        <p:txBody>
+          <a:bodyPr/>
+          <a:lstStyle/>
+          <a:p>
+            <a:fld id="{F7021451-1387-4CA6-816F-3879F97B5CBC}" type="slidenum">
+              <a:rPr lang="en-US"/>
+              <a:t>14</a:t>
             </a:fld>
             <a:endParaRPr lang="en-US"/>
           </a:p>
@@ -6063,6 +6152,403 @@
 </p:sld>
 </file>
 
+<file path=ppt/slides/slide14.xml><?xml version="1.0" encoding="utf-8"?>
+<p:sld xmlns:a="http://schemas.openxmlformats.org/drawingml/2006/main" xmlns:r="http://schemas.openxmlformats.org/officeDocument/2006/relationships" xmlns:p="http://schemas.openxmlformats.org/presentationml/2006/main">
+  <p:cSld name="Slide 14">
+    <p:bg>
+      <p:bgPr>
+        <a:solidFill>
+          <a:srgbClr val="1E2761"/>
+        </a:solidFill>
+      </p:bgPr>
+    </p:bg>
+    <p:spTree>
+      <p:nvGrpSpPr>
+        <p:cNvPr id="1" name=""/>
+        <p:cNvGrpSpPr/>
+        <p:nvPr/>
+      </p:nvGrpSpPr>
+      <p:grpSpPr>
+        <a:xfrm>
+          <a:off x="0" y="0"/>
+          <a:ext cx="0" cy="0"/>
+          <a:chOff x="0" y="0"/>
+          <a:chExt cx="0" cy="0"/>
+        </a:xfrm>
+      </p:grpSpPr>
+      <p:sp>
+        <p:nvSpPr>
+          <p:cNvPr id="2" name="Text 0"/>
+          <p:cNvSpPr/>
+          <p:nvPr/>
+        </p:nvSpPr>
+        <p:spPr>
+          <a:xfrm>
+            <a:off x="822960" y="1965960"/>
+            <a:ext cx="10515600" cy="1188720"/>
+          </a:xfrm>
+          <a:prstGeom prst="rect">
+            <a:avLst/>
+          </a:prstGeom>
+          <a:noFill/>
+          <a:ln/>
+        </p:spPr>
+        <p:txBody>
+          <a:bodyPr wrap="square" lIns="0" tIns="0" rIns="0" bIns="0" rtlCol="0" anchor="ctr"/>
+          <a:lstStyle/>
+          <a:p>
+            <a:pPr indent="0" marL="0">
+              <a:buNone/>
+            </a:pPr>
+            <a:r>
+              <a:rPr lang="en-US" sz="4600" b="1" dirty="0">
+                <a:solidFill>
+                  <a:srgbClr val="FFFFFF"/>
+                </a:solidFill>
+                <a:latin typeface="Cambria" pitchFamily="34" charset="0"/>
+                <a:ea typeface="Cambria" pitchFamily="34" charset="-122"/>
+                <a:cs typeface="Cambria" pitchFamily="34" charset="-120"/>
+              </a:rPr>
+              <a:t>Thank you.</a:t>
+            </a:r>
+            <a:endParaRPr lang="en-US" sz="4600" dirty="0"/>
+          </a:p>
+        </p:txBody>
+      </p:sp>
+      <p:sp>
+        <p:nvSpPr>
+          <p:cNvPr id="3" name="Text 1"/>
+          <p:cNvSpPr/>
+          <p:nvPr/>
+        </p:nvSpPr>
+        <p:spPr>
+          <a:xfrm>
+            <a:off x="822960" y="2880360"/>
+            <a:ext cx="10515600" cy="914400"/>
+          </a:xfrm>
+          <a:prstGeom prst="rect">
+            <a:avLst/>
+          </a:prstGeom>
+          <a:noFill/>
+          <a:ln/>
+        </p:spPr>
+        <p:txBody>
+          <a:bodyPr wrap="square" lIns="0" tIns="0" rIns="0" bIns="0" rtlCol="0" anchor="ctr"/>
+          <a:lstStyle/>
+          <a:p>
+            <a:pPr indent="0" marL="0">
+              <a:buNone/>
+            </a:pPr>
+            <a:r>
+              <a:rPr lang="en-US" sz="3000" i="1" dirty="0">
+                <a:solidFill>
+                  <a:srgbClr val="CADCFC"/>
+                </a:solidFill>
+                <a:latin typeface="Cambria" pitchFamily="34" charset="0"/>
+                <a:ea typeface="Cambria" pitchFamily="34" charset="-122"/>
+                <a:cs typeface="Cambria" pitchFamily="34" charset="-120"/>
+              </a:rPr>
+              <a:t>Questions?</a:t>
+            </a:r>
+            <a:endParaRPr lang="en-US" sz="3000" dirty="0"/>
+          </a:p>
+        </p:txBody>
+      </p:sp>
+      <p:sp>
+        <p:nvSpPr>
+          <p:cNvPr id="4" name="Shape 2"/>
+          <p:cNvSpPr/>
+          <p:nvPr/>
+        </p:nvSpPr>
+        <p:spPr>
+          <a:xfrm>
+            <a:off x="822960" y="4206240"/>
+            <a:ext cx="3840480" cy="0"/>
+          </a:xfrm>
+          <a:prstGeom prst="line">
+            <a:avLst/>
+          </a:prstGeom>
+          <a:noFill/>
+          <a:ln w="12700">
+            <a:solidFill>
+              <a:srgbClr val="3A4180"/>
+            </a:solidFill>
+            <a:prstDash val="solid"/>
+          </a:ln>
+        </p:spPr>
+      </p:sp>
+      <p:sp>
+        <p:nvSpPr>
+          <p:cNvPr id="5" name="Shape 3"/>
+          <p:cNvSpPr/>
+          <p:nvPr/>
+        </p:nvSpPr>
+        <p:spPr>
+          <a:xfrm>
+            <a:off x="822960" y="4626864"/>
+            <a:ext cx="109728" cy="109728"/>
+          </a:xfrm>
+          <a:prstGeom prst="ellipse">
+            <a:avLst/>
+          </a:prstGeom>
+          <a:solidFill>
+            <a:srgbClr val="C0392B"/>
+          </a:solidFill>
+          <a:ln/>
+        </p:spPr>
+      </p:sp>
+      <p:sp>
+        <p:nvSpPr>
+          <p:cNvPr id="6" name="Text 4"/>
+          <p:cNvSpPr/>
+          <p:nvPr/>
+        </p:nvSpPr>
+        <p:spPr>
+          <a:xfrm>
+            <a:off x="1143000" y="4443984"/>
+            <a:ext cx="9601200" cy="502920"/>
+          </a:xfrm>
+          <a:prstGeom prst="rect">
+            <a:avLst/>
+          </a:prstGeom>
+          <a:noFill/>
+          <a:ln/>
+        </p:spPr>
+        <p:txBody>
+          <a:bodyPr wrap="square" lIns="0" tIns="0" rIns="0" bIns="0" rtlCol="0" anchor="ctr"/>
+          <a:lstStyle/>
+          <a:p>
+            <a:pPr indent="0" marL="0">
+              <a:lnSpc>
+                <a:spcPct val="120000"/>
+              </a:lnSpc>
+              <a:buNone/>
+            </a:pPr>
+            <a:r>
+              <a:rPr lang="en-US" sz="1400" i="1" dirty="0">
+                <a:solidFill>
+                  <a:srgbClr val="CADCFC"/>
+                </a:solidFill>
+                <a:latin typeface="Calibri" pitchFamily="34" charset="0"/>
+                <a:ea typeface="Calibri" pitchFamily="34" charset="-122"/>
+                <a:cs typeface="Calibri" pitchFamily="34" charset="-120"/>
+              </a:rPr>
+              <a:t>Which architecture would you trust with a second external site added?</a:t>
+            </a:r>
+            <a:endParaRPr lang="en-US" sz="1400" dirty="0"/>
+          </a:p>
+        </p:txBody>
+      </p:sp>
+      <p:sp>
+        <p:nvSpPr>
+          <p:cNvPr id="7" name="Shape 5"/>
+          <p:cNvSpPr/>
+          <p:nvPr/>
+        </p:nvSpPr>
+        <p:spPr>
+          <a:xfrm>
+            <a:off x="822960" y="5193792"/>
+            <a:ext cx="109728" cy="109728"/>
+          </a:xfrm>
+          <a:prstGeom prst="ellipse">
+            <a:avLst/>
+          </a:prstGeom>
+          <a:solidFill>
+            <a:srgbClr val="C0392B"/>
+          </a:solidFill>
+          <a:ln/>
+        </p:spPr>
+      </p:sp>
+      <p:sp>
+        <p:nvSpPr>
+          <p:cNvPr id="8" name="Text 6"/>
+          <p:cNvSpPr/>
+          <p:nvPr/>
+        </p:nvSpPr>
+        <p:spPr>
+          <a:xfrm>
+            <a:off x="1143000" y="5010912"/>
+            <a:ext cx="9601200" cy="502920"/>
+          </a:xfrm>
+          <a:prstGeom prst="rect">
+            <a:avLst/>
+          </a:prstGeom>
+          <a:noFill/>
+          <a:ln/>
+        </p:spPr>
+        <p:txBody>
+          <a:bodyPr wrap="square" lIns="0" tIns="0" rIns="0" bIns="0" rtlCol="0" anchor="ctr"/>
+          <a:lstStyle/>
+          <a:p>
+            <a:pPr indent="0" marL="0">
+              <a:lnSpc>
+                <a:spcPct val="120000"/>
+              </a:lnSpc>
+              <a:buNone/>
+            </a:pPr>
+            <a:r>
+              <a:rPr lang="en-US" sz="1400" i="1" dirty="0">
+                <a:solidFill>
+                  <a:srgbClr val="CADCFC"/>
+                </a:solidFill>
+                <a:latin typeface="Calibri" pitchFamily="34" charset="0"/>
+                <a:ea typeface="Calibri" pitchFamily="34" charset="-122"/>
+                <a:cs typeface="Calibri" pitchFamily="34" charset="-120"/>
+              </a:rPr>
+              <a:t>Where should the shortcut-overlap threshold sit for a real deployment gate?</a:t>
+            </a:r>
+            <a:endParaRPr lang="en-US" sz="1400" dirty="0"/>
+          </a:p>
+        </p:txBody>
+      </p:sp>
+      <p:sp>
+        <p:nvSpPr>
+          <p:cNvPr id="9" name="Shape 7"/>
+          <p:cNvSpPr/>
+          <p:nvPr/>
+        </p:nvSpPr>
+        <p:spPr>
+          <a:xfrm>
+            <a:off x="822960" y="5760720"/>
+            <a:ext cx="109728" cy="109728"/>
+          </a:xfrm>
+          <a:prstGeom prst="ellipse">
+            <a:avLst/>
+          </a:prstGeom>
+          <a:solidFill>
+            <a:srgbClr val="C0392B"/>
+          </a:solidFill>
+          <a:ln/>
+        </p:spPr>
+      </p:sp>
+      <p:sp>
+        <p:nvSpPr>
+          <p:cNvPr id="10" name="Text 8"/>
+          <p:cNvSpPr/>
+          <p:nvPr/>
+        </p:nvSpPr>
+        <p:spPr>
+          <a:xfrm>
+            <a:off x="1143000" y="5577840"/>
+            <a:ext cx="9601200" cy="502920"/>
+          </a:xfrm>
+          <a:prstGeom prst="rect">
+            <a:avLst/>
+          </a:prstGeom>
+          <a:noFill/>
+          <a:ln/>
+        </p:spPr>
+        <p:txBody>
+          <a:bodyPr wrap="square" lIns="0" tIns="0" rIns="0" bIns="0" rtlCol="0" anchor="ctr"/>
+          <a:lstStyle/>
+          <a:p>
+            <a:pPr indent="0" marL="0">
+              <a:lnSpc>
+                <a:spcPct val="120000"/>
+              </a:lnSpc>
+              <a:buNone/>
+            </a:pPr>
+            <a:r>
+              <a:rPr lang="en-US" sz="1400" i="1" dirty="0">
+                <a:solidFill>
+                  <a:srgbClr val="CADCFC"/>
+                </a:solidFill>
+                <a:latin typeface="Calibri" pitchFamily="34" charset="0"/>
+                <a:ea typeface="Calibri" pitchFamily="34" charset="-122"/>
+                <a:cs typeface="Calibri" pitchFamily="34" charset="-120"/>
+              </a:rPr>
+              <a:t>What would change your mind about the age-artifact causal result?</a:t>
+            </a:r>
+            <a:endParaRPr lang="en-US" sz="1400" dirty="0"/>
+          </a:p>
+        </p:txBody>
+      </p:sp>
+      <p:sp>
+        <p:nvSpPr>
+          <p:cNvPr id="11" name="Text 9"/>
+          <p:cNvSpPr/>
+          <p:nvPr/>
+        </p:nvSpPr>
+        <p:spPr>
+          <a:xfrm>
+            <a:off x="822960" y="6263640"/>
+            <a:ext cx="10515600" cy="320040"/>
+          </a:xfrm>
+          <a:prstGeom prst="rect">
+            <a:avLst/>
+          </a:prstGeom>
+          <a:noFill/>
+          <a:ln/>
+        </p:spPr>
+        <p:txBody>
+          <a:bodyPr wrap="square" lIns="0" tIns="0" rIns="0" bIns="0" rtlCol="0" anchor="ctr"/>
+          <a:lstStyle/>
+          <a:p>
+            <a:pPr indent="0" marL="0">
+              <a:buNone/>
+            </a:pPr>
+            <a:r>
+              <a:rPr lang="en-US" sz="1100" dirty="0">
+                <a:solidFill>
+                  <a:srgbClr val="8A93C4"/>
+                </a:solidFill>
+                <a:latin typeface="Calibri" pitchFamily="34" charset="0"/>
+                <a:ea typeface="Calibri" pitchFamily="34" charset="-122"/>
+                <a:cs typeface="Calibri" pitchFamily="34" charset="-120"/>
+              </a:rPr>
+              <a:t>Code, report, and results: github.com/Charith-Reddy-Pareddy/medical-image-classification-for-disease-detection</a:t>
+            </a:r>
+            <a:endParaRPr lang="en-US" sz="1100" dirty="0"/>
+          </a:p>
+        </p:txBody>
+      </p:sp>
+      <p:sp>
+        <p:nvSpPr>
+          <p:cNvPr id="12" name="Text 10"/>
+          <p:cNvSpPr/>
+          <p:nvPr/>
+        </p:nvSpPr>
+        <p:spPr>
+          <a:xfrm>
+            <a:off x="11365992" y="6400800"/>
+            <a:ext cx="457200" cy="274320"/>
+          </a:xfrm>
+          <a:prstGeom prst="rect">
+            <a:avLst/>
+          </a:prstGeom>
+          <a:noFill/>
+          <a:ln/>
+        </p:spPr>
+        <p:txBody>
+          <a:bodyPr wrap="square" lIns="0" tIns="0" rIns="0" bIns="0" rtlCol="0" anchor="ctr"/>
+          <a:lstStyle/>
+          <a:p>
+            <a:pPr algn="r" indent="0" marL="0">
+              <a:buNone/>
+            </a:pPr>
+            <a:r>
+              <a:rPr lang="en-US" sz="1000" dirty="0">
+                <a:solidFill>
+                  <a:srgbClr val="8A93C4"/>
+                </a:solidFill>
+                <a:latin typeface="Calibri" pitchFamily="34" charset="0"/>
+                <a:ea typeface="Calibri" pitchFamily="34" charset="-122"/>
+                <a:cs typeface="Calibri" pitchFamily="34" charset="-120"/>
+              </a:rPr>
+              <a:t>14</a:t>
+            </a:r>
+            <a:endParaRPr lang="en-US" sz="1000" dirty="0"/>
+          </a:p>
+        </p:txBody>
+      </p:sp>
+    </p:spTree>
+  </p:cSld>
+  <p:clrMapOvr>
+    <a:masterClrMapping/>
+  </p:clrMapOvr>
+</p:sld>
+</file>
+
 <file path=ppt/slides/slide2.xml><?xml version="1.0" encoding="utf-8"?>
 <p:sld xmlns:a="http://schemas.openxmlformats.org/drawingml/2006/main" xmlns:r="http://schemas.openxmlformats.org/officeDocument/2006/relationships" xmlns:p="http://schemas.openxmlformats.org/presentationml/2006/main">
   <p:cSld name="Slide 2">

</xml_diff>